<commit_message>
Rebuild: split tracks, Departures v2, booking-site UI, drawio ER, themed slides/PDF, split viva notes
</commit_message>
<xml_diff>
--- a/dbms/docs/SkyRoute_Slides.pptx
+++ b/dbms/docs/SkyRoute_Slides.pptx
@@ -3100,14 +3100,57 @@
       <p:grpSpPr/>
       <p:sp>
         <p:nvSpPr>
-          <p:cNvPr id="2" name="TextBox 1"/>
+          <p:cNvPr id="2" name="Rectangle 1"/>
+          <p:cNvSpPr/>
+          <p:nvPr/>
+        </p:nvSpPr>
+        <p:spPr>
+          <a:xfrm>
+            <a:off x="0" y="0"/>
+            <a:ext cx="12192000" cy="6858000"/>
+          </a:xfrm>
+          <a:prstGeom prst="rect">
+            <a:avLst/>
+          </a:prstGeom>
+          <a:solidFill>
+            <a:srgbClr val="0F2540"/>
+          </a:solidFill>
+          <a:ln>
+            <a:noFill/>
+          </a:ln>
+        </p:spPr>
+        <p:style>
+          <a:lnRef idx="1">
+            <a:schemeClr val="accent1"/>
+          </a:lnRef>
+          <a:fillRef idx="3">
+            <a:schemeClr val="accent1"/>
+          </a:fillRef>
+          <a:effectRef idx="2">
+            <a:schemeClr val="accent1"/>
+          </a:effectRef>
+          <a:fontRef idx="minor">
+            <a:schemeClr val="lt1"/>
+          </a:fontRef>
+        </p:style>
+        <p:txBody>
+          <a:bodyPr rtlCol="0" anchor="ctr"/>
+          <a:lstStyle/>
+          <a:p>
+            <a:pPr algn="ctr"/>
+          </a:p>
+        </p:txBody>
+      </p:sp>
+      <p:sp>
+        <p:nvSpPr>
+          <p:cNvPr id="3" name="TextBox 2"/>
           <p:cNvSpPr txBox="1"/>
           <p:nvPr/>
         </p:nvSpPr>
         <p:spPr>
           <a:xfrm>
-            <a:off x="508000" y="254000"/>
-            <a:ext cx="11176000" cy="1016000"/>
+            <a:off x="762000" y="1524000"/>
+            <a:ext cx="10668000" cy="3810000"/>
           </a:xfrm>
           <a:prstGeom prst="rect">
             <a:avLst/>
@@ -3115,58 +3158,68 @@
           <a:noFill/>
         </p:spPr>
         <p:txBody>
-          <a:bodyPr wrap="none">
-            <a:spAutoFit/>
-          </a:bodyPr>
-          <a:lstStyle/>
-          <a:p>
-            <a:r>
-              <a:rPr sz="3200" b="1"/>
-              <a:t>SkyRoute: Airline Ticket &amp; Baggage System</a:t>
-            </a:r>
-          </a:p>
-        </p:txBody>
-      </p:sp>
-      <p:sp>
-        <p:nvSpPr>
-          <p:cNvPr id="3" name="TextBox 2"/>
-          <p:cNvSpPr txBox="1"/>
-          <p:nvPr/>
-        </p:nvSpPr>
-        <p:spPr>
-          <a:xfrm>
-            <a:off x="508000" y="1524000"/>
-            <a:ext cx="11176000" cy="4826000"/>
-          </a:xfrm>
-          <a:prstGeom prst="rect">
-            <a:avLst/>
-          </a:prstGeom>
-          <a:noFill/>
-        </p:spPr>
-        <p:txBody>
           <a:bodyPr wrap="square">
             <a:spAutoFit/>
           </a:bodyPr>
           <a:lstStyle/>
           <a:p>
-            <a:pPr/>
-            <a:r>
-              <a:rPr sz="2000"/>
-              <a:t>•  Multi-airport DBMS mini project — MySQL 8.0, database skyroute_db</a:t>
-            </a:r>
-          </a:p>
-          <a:p>
-            <a:pPr/>
-            <a:r>
-              <a:rPr sz="2000"/>
-              <a:t>•  5 airports, 3 airlines, 140 dated departures, ~14,000 bookings</a:t>
-            </a:r>
-          </a:p>
-          <a:p>
-            <a:pPr/>
-            <a:r>
-              <a:rPr sz="2000"/>
-              <a:t>•  Every manual-system failure maps to one database mechanism</a:t>
+            <a:pPr>
+              <a:spcAft>
+                <a:spcPts val="1000"/>
+              </a:spcAft>
+            </a:pPr>
+            <a:r>
+              <a:rPr sz="2000" b="1">
+                <a:solidFill>
+                  <a:srgbClr val="F5A623"/>
+                </a:solidFill>
+              </a:rPr>
+              <a:t>SKYROUTE  ✈</a:t>
+            </a:r>
+          </a:p>
+          <a:p>
+            <a:pPr>
+              <a:spcAft>
+                <a:spcPts val="1000"/>
+              </a:spcAft>
+            </a:pPr>
+            <a:r>
+              <a:rPr sz="4400" b="1">
+                <a:solidFill>
+                  <a:srgbClr val="FFFFFF"/>
+                </a:solidFill>
+              </a:rPr>
+              <a:t>Airline Ticket &amp; Baggage System</a:t>
+            </a:r>
+          </a:p>
+          <a:p>
+            <a:pPr>
+              <a:spcAft>
+                <a:spcPts val="1000"/>
+              </a:spcAft>
+            </a:pPr>
+            <a:r>
+              <a:rPr sz="2000" b="0">
+                <a:solidFill>
+                  <a:srgbClr val="CFE3F7"/>
+                </a:solidFill>
+              </a:rPr>
+              <a:t>Multi-airport database · 16 tables · 140 departures · ~14,000 bookings</a:t>
+            </a:r>
+          </a:p>
+          <a:p>
+            <a:pPr>
+              <a:spcAft>
+                <a:spcPts val="1000"/>
+              </a:spcAft>
+            </a:pPr>
+            <a:r>
+              <a:rPr sz="2000" b="0">
+                <a:solidFill>
+                  <a:srgbClr val="CFE3F7"/>
+                </a:solidFill>
+              </a:rPr>
+              <a:t>Views · trigger · procedure · transactions · indexes · Flask booking site</a:t>
             </a:r>
           </a:p>
         </p:txBody>
@@ -3191,14 +3244,57 @@
       <p:grpSpPr/>
       <p:sp>
         <p:nvSpPr>
-          <p:cNvPr id="2" name="TextBox 1"/>
+          <p:cNvPr id="2" name="Rectangle 1"/>
+          <p:cNvSpPr/>
+          <p:nvPr/>
+        </p:nvSpPr>
+        <p:spPr>
+          <a:xfrm>
+            <a:off x="0" y="0"/>
+            <a:ext cx="12192000" cy="1651000"/>
+          </a:xfrm>
+          <a:prstGeom prst="rect">
+            <a:avLst/>
+          </a:prstGeom>
+          <a:solidFill>
+            <a:srgbClr val="0F2540"/>
+          </a:solidFill>
+          <a:ln>
+            <a:noFill/>
+          </a:ln>
+        </p:spPr>
+        <p:style>
+          <a:lnRef idx="1">
+            <a:schemeClr val="accent1"/>
+          </a:lnRef>
+          <a:fillRef idx="3">
+            <a:schemeClr val="accent1"/>
+          </a:fillRef>
+          <a:effectRef idx="2">
+            <a:schemeClr val="accent1"/>
+          </a:effectRef>
+          <a:fontRef idx="minor">
+            <a:schemeClr val="lt1"/>
+          </a:fontRef>
+        </p:style>
+        <p:txBody>
+          <a:bodyPr rtlCol="0" anchor="ctr"/>
+          <a:lstStyle/>
+          <a:p>
+            <a:pPr algn="ctr"/>
+          </a:p>
+        </p:txBody>
+      </p:sp>
+      <p:sp>
+        <p:nvSpPr>
+          <p:cNvPr id="3" name="TextBox 2"/>
           <p:cNvSpPr txBox="1"/>
           <p:nvPr/>
         </p:nvSpPr>
         <p:spPr>
           <a:xfrm>
-            <a:off x="508000" y="254000"/>
-            <a:ext cx="11176000" cy="1016000"/>
+            <a:off x="609600" y="279400"/>
+            <a:ext cx="10972800" cy="381000"/>
           </a:xfrm>
           <a:prstGeom prst="rect">
             <a:avLst/>
@@ -3206,28 +3302,32 @@
           <a:noFill/>
         </p:spPr>
         <p:txBody>
-          <a:bodyPr wrap="none">
+          <a:bodyPr wrap="square">
             <a:spAutoFit/>
           </a:bodyPr>
           <a:lstStyle/>
           <a:p>
             <a:r>
-              <a:rPr sz="3200" b="1"/>
-              <a:t>Testing</a:t>
-            </a:r>
-          </a:p>
-        </p:txBody>
-      </p:sp>
-      <p:sp>
-        <p:nvSpPr>
-          <p:cNvPr id="3" name="TextBox 2"/>
+              <a:rPr sz="1300" b="1">
+                <a:solidFill>
+                  <a:srgbClr val="F5A623"/>
+                </a:solidFill>
+              </a:rPr>
+              <a:t>SKYROUTE</a:t>
+            </a:r>
+          </a:p>
+        </p:txBody>
+      </p:sp>
+      <p:sp>
+        <p:nvSpPr>
+          <p:cNvPr id="4" name="TextBox 3"/>
           <p:cNvSpPr txBox="1"/>
           <p:nvPr/>
         </p:nvSpPr>
         <p:spPr>
           <a:xfrm>
-            <a:off x="508000" y="1524000"/>
-            <a:ext cx="11176000" cy="4826000"/>
+            <a:off x="609600" y="609600"/>
+            <a:ext cx="10972800" cy="889000"/>
           </a:xfrm>
           <a:prstGeom prst="rect">
             <a:avLst/>
@@ -3240,24 +3340,161 @@
           </a:bodyPr>
           <a:lstStyle/>
           <a:p>
-            <a:pPr/>
-            <a:r>
-              <a:rPr sz="2000"/>
-              <a:t>•  30 checks in 8 groups (docs/TESTING.md): joins, analytics,</a:t>
-            </a:r>
-          </a:p>
-          <a:p>
-            <a:pPr/>
-            <a:r>
-              <a:rPr sz="2000"/>
-              <a:t>•  constraint rejections, atomicity, demos, EXPLAIN pairs, grants, scale</a:t>
-            </a:r>
-          </a:p>
-          <a:p>
-            <a:pPr/>
-            <a:r>
-              <a:rPr sz="2000"/>
-              <a:t>•  Every check states its expected result before the run</a:t>
+            <a:r>
+              <a:rPr sz="3000" b="1">
+                <a:solidFill>
+                  <a:srgbClr val="FFFFFF"/>
+                </a:solidFill>
+              </a:rPr>
+              <a:t>Flask booking site: the database, clickable</a:t>
+            </a:r>
+          </a:p>
+        </p:txBody>
+      </p:sp>
+      <p:sp>
+        <p:nvSpPr>
+          <p:cNvPr id="5" name="TextBox 4"/>
+          <p:cNvSpPr txBox="1"/>
+          <p:nvPr/>
+        </p:nvSpPr>
+        <p:spPr>
+          <a:xfrm>
+            <a:off x="609600" y="6350000"/>
+            <a:ext cx="10972800" cy="304800"/>
+          </a:xfrm>
+          <a:prstGeom prst="rect">
+            <a:avLst/>
+          </a:prstGeom>
+          <a:noFill/>
+        </p:spPr>
+        <p:txBody>
+          <a:bodyPr wrap="square">
+            <a:spAutoFit/>
+          </a:bodyPr>
+          <a:lstStyle/>
+          <a:p>
+            <a:r>
+              <a:rPr sz="1100">
+                <a:solidFill>
+                  <a:srgbClr val="5B6B7F"/>
+                </a:solidFill>
+              </a:rPr>
+              <a:t>SkyRoute  ·  DBMS mini project  ·  skyroute_db (MySQL 8.0)</a:t>
+            </a:r>
+          </a:p>
+        </p:txBody>
+      </p:sp>
+      <p:sp>
+        <p:nvSpPr>
+          <p:cNvPr id="6" name="TextBox 5"/>
+          <p:cNvSpPr txBox="1"/>
+          <p:nvPr/>
+        </p:nvSpPr>
+        <p:spPr>
+          <a:xfrm>
+            <a:off x="609600" y="1905000"/>
+            <a:ext cx="10972800" cy="4191000"/>
+          </a:xfrm>
+          <a:prstGeom prst="rect">
+            <a:avLst/>
+          </a:prstGeom>
+          <a:noFill/>
+        </p:spPr>
+        <p:txBody>
+          <a:bodyPr wrap="square">
+            <a:spAutoFit/>
+          </a:bodyPr>
+          <a:lstStyle/>
+          <a:p>
+            <a:pPr>
+              <a:spcAft>
+                <a:spcPts val="1000"/>
+              </a:spcAft>
+            </a:pPr>
+            <a:r>
+              <a:rPr sz="1900" b="1">
+                <a:solidFill>
+                  <a:srgbClr val="0F2540"/>
+                </a:solidFill>
+              </a:rPr>
+              <a:t>▸ 3 steps  </a:t>
+            </a:r>
+            <a:r>
+              <a:rPr sz="1900">
+                <a:solidFill>
+                  <a:srgbClr val="222222"/>
+                </a:solidFill>
+              </a:rPr>
+              <a:t>Search → seat map → My bookings (http://127.0.0.1:5000).</a:t>
+            </a:r>
+          </a:p>
+          <a:p>
+            <a:pPr>
+              <a:spcAft>
+                <a:spcPts val="1000"/>
+              </a:spcAft>
+            </a:pPr>
+            <a:r>
+              <a:rPr sz="1900" b="1">
+                <a:solidFill>
+                  <a:srgbClr val="0F2540"/>
+                </a:solidFill>
+              </a:rPr>
+              <a:t>▸ Seat map  </a:t>
+            </a:r>
+            <a:r>
+              <a:rPr sz="1900">
+                <a:solidFill>
+                  <a:srgbClr val="222222"/>
+                </a:solidFill>
+              </a:rPr>
+              <a:t>grey seats are the UNIQUE key made visible.</a:t>
+            </a:r>
+          </a:p>
+          <a:p>
+            <a:pPr>
+              <a:spcAft>
+                <a:spcPts val="1000"/>
+              </a:spcAft>
+            </a:pPr>
+            <a:r>
+              <a:rPr sz="1900" b="1">
+                <a:solidFill>
+                  <a:srgbClr val="0F2540"/>
+                </a:solidFill>
+              </a:rPr>
+              <a:t>▸ CRUD + fee  </a:t>
+            </a:r>
+            <a:r>
+              <a:rPr sz="1900">
+                <a:solidFill>
+                  <a:srgbClr val="222222"/>
+                </a:solidFill>
+              </a:rPr>
+              <a:t>edit · cancel · delete · 25 kg bag = Rs 2,500 fee.</a:t>
+            </a:r>
+          </a:p>
+          <a:p>
+            <a:pPr>
+              <a:spcAft>
+                <a:spcPts val="1000"/>
+              </a:spcAft>
+            </a:pPr>
+            <a:r>
+              <a:rPr sz="1900" b="1">
+                <a:solidFill>
+                  <a:srgbClr val="0F2540"/>
+                </a:solidFill>
+              </a:rPr>
+              <a:t>▸ 13 tests  </a:t>
+            </a:r>
+            <a:r>
+              <a:rPr sz="1900">
+                <a:solidFill>
+                  <a:srgbClr val="222222"/>
+                </a:solidFill>
+              </a:rPr>
+              <a:t>all passing, no server needed: test_app.py.</a:t>
             </a:r>
           </a:p>
         </p:txBody>
@@ -3282,14 +3519,57 @@
       <p:grpSpPr/>
       <p:sp>
         <p:nvSpPr>
-          <p:cNvPr id="2" name="TextBox 1"/>
+          <p:cNvPr id="2" name="Rectangle 1"/>
+          <p:cNvSpPr/>
+          <p:nvPr/>
+        </p:nvSpPr>
+        <p:spPr>
+          <a:xfrm>
+            <a:off x="0" y="0"/>
+            <a:ext cx="12192000" cy="1651000"/>
+          </a:xfrm>
+          <a:prstGeom prst="rect">
+            <a:avLst/>
+          </a:prstGeom>
+          <a:solidFill>
+            <a:srgbClr val="0F2540"/>
+          </a:solidFill>
+          <a:ln>
+            <a:noFill/>
+          </a:ln>
+        </p:spPr>
+        <p:style>
+          <a:lnRef idx="1">
+            <a:schemeClr val="accent1"/>
+          </a:lnRef>
+          <a:fillRef idx="3">
+            <a:schemeClr val="accent1"/>
+          </a:fillRef>
+          <a:effectRef idx="2">
+            <a:schemeClr val="accent1"/>
+          </a:effectRef>
+          <a:fontRef idx="minor">
+            <a:schemeClr val="lt1"/>
+          </a:fontRef>
+        </p:style>
+        <p:txBody>
+          <a:bodyPr rtlCol="0" anchor="ctr"/>
+          <a:lstStyle/>
+          <a:p>
+            <a:pPr algn="ctr"/>
+          </a:p>
+        </p:txBody>
+      </p:sp>
+      <p:sp>
+        <p:nvSpPr>
+          <p:cNvPr id="3" name="TextBox 2"/>
           <p:cNvSpPr txBox="1"/>
           <p:nvPr/>
         </p:nvSpPr>
         <p:spPr>
           <a:xfrm>
-            <a:off x="508000" y="254000"/>
-            <a:ext cx="11176000" cy="1016000"/>
+            <a:off x="609600" y="279400"/>
+            <a:ext cx="10972800" cy="381000"/>
           </a:xfrm>
           <a:prstGeom prst="rect">
             <a:avLst/>
@@ -3297,28 +3577,32 @@
           <a:noFill/>
         </p:spPr>
         <p:txBody>
-          <a:bodyPr wrap="none">
+          <a:bodyPr wrap="square">
             <a:spAutoFit/>
           </a:bodyPr>
           <a:lstStyle/>
           <a:p>
             <a:r>
-              <a:rPr sz="3200" b="1"/>
-              <a:t>Conclusion + next step</a:t>
-            </a:r>
-          </a:p>
-        </p:txBody>
-      </p:sp>
-      <p:sp>
-        <p:nvSpPr>
-          <p:cNvPr id="3" name="TextBox 2"/>
+              <a:rPr sz="1300" b="1">
+                <a:solidFill>
+                  <a:srgbClr val="F5A623"/>
+                </a:solidFill>
+              </a:rPr>
+              <a:t>SKYROUTE</a:t>
+            </a:r>
+          </a:p>
+        </p:txBody>
+      </p:sp>
+      <p:sp>
+        <p:nvSpPr>
+          <p:cNvPr id="4" name="TextBox 3"/>
           <p:cNvSpPr txBox="1"/>
           <p:nvPr/>
         </p:nvSpPr>
         <p:spPr>
           <a:xfrm>
-            <a:off x="508000" y="1524000"/>
-            <a:ext cx="11176000" cy="4826000"/>
+            <a:off x="609600" y="609600"/>
+            <a:ext cx="10972800" cy="889000"/>
           </a:xfrm>
           <a:prstGeom prst="rect">
             <a:avLst/>
@@ -3331,24 +3615,138 @@
           </a:bodyPr>
           <a:lstStyle/>
           <a:p>
-            <a:pPr/>
-            <a:r>
-              <a:rPr sz="2000"/>
-              <a:t>•  All 5 problem items closed by named mechanisms, all tested</a:t>
-            </a:r>
-          </a:p>
-          <a:p>
-            <a:pPr/>
-            <a:r>
-              <a:rPr sz="2000"/>
-              <a:t>•  Flask + sqlite3 web project reuses this design with full CRUD</a:t>
-            </a:r>
-          </a:p>
-          <a:p>
-            <a:pPr/>
-            <a:r>
-              <a:rPr sz="2000"/>
-              <a:t>•  Demo: departure board, live booking, duplicate-seat refusal, fee receipt</a:t>
+            <a:r>
+              <a:rPr sz="3000" b="1">
+                <a:solidFill>
+                  <a:srgbClr val="FFFFFF"/>
+                </a:solidFill>
+              </a:rPr>
+              <a:t>Result: every problem closed, everything tested</a:t>
+            </a:r>
+          </a:p>
+        </p:txBody>
+      </p:sp>
+      <p:sp>
+        <p:nvSpPr>
+          <p:cNvPr id="5" name="TextBox 4"/>
+          <p:cNvSpPr txBox="1"/>
+          <p:nvPr/>
+        </p:nvSpPr>
+        <p:spPr>
+          <a:xfrm>
+            <a:off x="609600" y="6350000"/>
+            <a:ext cx="10972800" cy="304800"/>
+          </a:xfrm>
+          <a:prstGeom prst="rect">
+            <a:avLst/>
+          </a:prstGeom>
+          <a:noFill/>
+        </p:spPr>
+        <p:txBody>
+          <a:bodyPr wrap="square">
+            <a:spAutoFit/>
+          </a:bodyPr>
+          <a:lstStyle/>
+          <a:p>
+            <a:r>
+              <a:rPr sz="1100">
+                <a:solidFill>
+                  <a:srgbClr val="5B6B7F"/>
+                </a:solidFill>
+              </a:rPr>
+              <a:t>SkyRoute  ·  DBMS mini project  ·  skyroute_db (MySQL 8.0)</a:t>
+            </a:r>
+          </a:p>
+        </p:txBody>
+      </p:sp>
+      <p:sp>
+        <p:nvSpPr>
+          <p:cNvPr id="6" name="TextBox 5"/>
+          <p:cNvSpPr txBox="1"/>
+          <p:nvPr/>
+        </p:nvSpPr>
+        <p:spPr>
+          <a:xfrm>
+            <a:off x="609600" y="1905000"/>
+            <a:ext cx="10972800" cy="4191000"/>
+          </a:xfrm>
+          <a:prstGeom prst="rect">
+            <a:avLst/>
+          </a:prstGeom>
+          <a:noFill/>
+        </p:spPr>
+        <p:txBody>
+          <a:bodyPr wrap="square">
+            <a:spAutoFit/>
+          </a:bodyPr>
+          <a:lstStyle/>
+          <a:p>
+            <a:pPr>
+              <a:spcAft>
+                <a:spcPts val="1000"/>
+              </a:spcAft>
+            </a:pPr>
+            <a:r>
+              <a:rPr sz="1900" b="1">
+                <a:solidFill>
+                  <a:srgbClr val="0F2540"/>
+                </a:solidFill>
+              </a:rPr>
+              <a:t>▸ Coverage  </a:t>
+            </a:r>
+            <a:r>
+              <a:rPr sz="1900">
+                <a:solidFill>
+                  <a:srgbClr val="222222"/>
+                </a:solidFill>
+              </a:rPr>
+              <a:t>all 5 problem items → named mechanisms → tests.</a:t>
+            </a:r>
+          </a:p>
+          <a:p>
+            <a:pPr>
+              <a:spcAft>
+                <a:spcPts val="1000"/>
+              </a:spcAft>
+            </a:pPr>
+            <a:r>
+              <a:rPr sz="1900" b="1">
+                <a:solidFill>
+                  <a:srgbClr val="0F2540"/>
+                </a:solidFill>
+              </a:rPr>
+              <a:t>▸ Volume  </a:t>
+            </a:r>
+            <a:r>
+              <a:rPr sz="1900">
+                <a:solidFill>
+                  <a:srgbClr val="222222"/>
+                </a:solidFill>
+              </a:rPr>
+              <a:t>~14k bookings answered in single queries.</a:t>
+            </a:r>
+          </a:p>
+          <a:p>
+            <a:pPr>
+              <a:spcAft>
+                <a:spcPts val="1000"/>
+              </a:spcAft>
+            </a:pPr>
+            <a:r>
+              <a:rPr sz="1900" b="1">
+                <a:solidFill>
+                  <a:srgbClr val="0F2540"/>
+                </a:solidFill>
+              </a:rPr>
+              <a:t>▸ Next  </a:t>
+            </a:r>
+            <a:r>
+              <a:rPr sz="1900">
+                <a:solidFill>
+                  <a:srgbClr val="222222"/>
+                </a:solidFill>
+              </a:rPr>
+              <a:t>live demo: board → book 12A → re-book 12A (refused) → fee receipt.</a:t>
             </a:r>
           </a:p>
         </p:txBody>
@@ -3373,14 +3771,57 @@
       <p:grpSpPr/>
       <p:sp>
         <p:nvSpPr>
-          <p:cNvPr id="2" name="TextBox 1"/>
+          <p:cNvPr id="2" name="Rectangle 1"/>
+          <p:cNvSpPr/>
+          <p:nvPr/>
+        </p:nvSpPr>
+        <p:spPr>
+          <a:xfrm>
+            <a:off x="0" y="0"/>
+            <a:ext cx="12192000" cy="1651000"/>
+          </a:xfrm>
+          <a:prstGeom prst="rect">
+            <a:avLst/>
+          </a:prstGeom>
+          <a:solidFill>
+            <a:srgbClr val="0F2540"/>
+          </a:solidFill>
+          <a:ln>
+            <a:noFill/>
+          </a:ln>
+        </p:spPr>
+        <p:style>
+          <a:lnRef idx="1">
+            <a:schemeClr val="accent1"/>
+          </a:lnRef>
+          <a:fillRef idx="3">
+            <a:schemeClr val="accent1"/>
+          </a:fillRef>
+          <a:effectRef idx="2">
+            <a:schemeClr val="accent1"/>
+          </a:effectRef>
+          <a:fontRef idx="minor">
+            <a:schemeClr val="lt1"/>
+          </a:fontRef>
+        </p:style>
+        <p:txBody>
+          <a:bodyPr rtlCol="0" anchor="ctr"/>
+          <a:lstStyle/>
+          <a:p>
+            <a:pPr algn="ctr"/>
+          </a:p>
+        </p:txBody>
+      </p:sp>
+      <p:sp>
+        <p:nvSpPr>
+          <p:cNvPr id="3" name="TextBox 2"/>
           <p:cNvSpPr txBox="1"/>
           <p:nvPr/>
         </p:nvSpPr>
         <p:spPr>
           <a:xfrm>
-            <a:off x="508000" y="254000"/>
-            <a:ext cx="11176000" cy="1016000"/>
+            <a:off x="609600" y="279400"/>
+            <a:ext cx="10972800" cy="381000"/>
           </a:xfrm>
           <a:prstGeom prst="rect">
             <a:avLst/>
@@ -3388,28 +3829,32 @@
           <a:noFill/>
         </p:spPr>
         <p:txBody>
-          <a:bodyPr wrap="none">
+          <a:bodyPr wrap="square">
             <a:spAutoFit/>
           </a:bodyPr>
           <a:lstStyle/>
           <a:p>
             <a:r>
-              <a:rPr sz="3200" b="1"/>
-              <a:t>Problem statement</a:t>
-            </a:r>
-          </a:p>
-        </p:txBody>
-      </p:sp>
-      <p:sp>
-        <p:nvSpPr>
-          <p:cNvPr id="3" name="TextBox 2"/>
+              <a:rPr sz="1300" b="1">
+                <a:solidFill>
+                  <a:srgbClr val="F5A623"/>
+                </a:solidFill>
+              </a:rPr>
+              <a:t>SKYROUTE</a:t>
+            </a:r>
+          </a:p>
+        </p:txBody>
+      </p:sp>
+      <p:sp>
+        <p:nvSpPr>
+          <p:cNvPr id="4" name="TextBox 3"/>
           <p:cNvSpPr txBox="1"/>
           <p:nvPr/>
         </p:nvSpPr>
         <p:spPr>
           <a:xfrm>
-            <a:off x="508000" y="1524000"/>
-            <a:ext cx="11176000" cy="4826000"/>
+            <a:off x="609600" y="609600"/>
+            <a:ext cx="10972800" cy="889000"/>
           </a:xfrm>
           <a:prstGeom prst="rect">
             <a:avLst/>
@@ -3422,31 +3867,184 @@
           </a:bodyPr>
           <a:lstStyle/>
           <a:p>
-            <a:pPr/>
-            <a:r>
-              <a:rPr sz="2000"/>
-              <a:t>•  Duplicate seat booking by concurrent agents</a:t>
-            </a:r>
-          </a:p>
-          <a:p>
-            <a:pPr/>
-            <a:r>
-              <a:rPr sz="2000"/>
-              <a:t>•  Gate assignment clashes between flights</a:t>
-            </a:r>
-          </a:p>
-          <a:p>
-            <a:pPr/>
-            <a:r>
-              <a:rPr sz="2000"/>
-              <a:t>•  Baggage fee miscalculated above 20 kg</a:t>
-            </a:r>
-          </a:p>
-          <a:p>
-            <a:pPr/>
-            <a:r>
-              <a:rPr sz="2000"/>
-              <a:t>•  No single database across stations; overselling past capacity</a:t>
+            <a:r>
+              <a:rPr sz="3000" b="1">
+                <a:solidFill>
+                  <a:srgbClr val="FFFFFF"/>
+                </a:solidFill>
+              </a:rPr>
+              <a:t>The problem: five failures, five mechanisms</a:t>
+            </a:r>
+          </a:p>
+        </p:txBody>
+      </p:sp>
+      <p:sp>
+        <p:nvSpPr>
+          <p:cNvPr id="5" name="TextBox 4"/>
+          <p:cNvSpPr txBox="1"/>
+          <p:nvPr/>
+        </p:nvSpPr>
+        <p:spPr>
+          <a:xfrm>
+            <a:off x="609600" y="6350000"/>
+            <a:ext cx="10972800" cy="304800"/>
+          </a:xfrm>
+          <a:prstGeom prst="rect">
+            <a:avLst/>
+          </a:prstGeom>
+          <a:noFill/>
+        </p:spPr>
+        <p:txBody>
+          <a:bodyPr wrap="square">
+            <a:spAutoFit/>
+          </a:bodyPr>
+          <a:lstStyle/>
+          <a:p>
+            <a:r>
+              <a:rPr sz="1100">
+                <a:solidFill>
+                  <a:srgbClr val="5B6B7F"/>
+                </a:solidFill>
+              </a:rPr>
+              <a:t>SkyRoute  ·  DBMS mini project  ·  skyroute_db (MySQL 8.0)</a:t>
+            </a:r>
+          </a:p>
+        </p:txBody>
+      </p:sp>
+      <p:sp>
+        <p:nvSpPr>
+          <p:cNvPr id="6" name="TextBox 5"/>
+          <p:cNvSpPr txBox="1"/>
+          <p:nvPr/>
+        </p:nvSpPr>
+        <p:spPr>
+          <a:xfrm>
+            <a:off x="609600" y="1905000"/>
+            <a:ext cx="10972800" cy="4191000"/>
+          </a:xfrm>
+          <a:prstGeom prst="rect">
+            <a:avLst/>
+          </a:prstGeom>
+          <a:noFill/>
+        </p:spPr>
+        <p:txBody>
+          <a:bodyPr wrap="square">
+            <a:spAutoFit/>
+          </a:bodyPr>
+          <a:lstStyle/>
+          <a:p>
+            <a:pPr>
+              <a:spcAft>
+                <a:spcPts val="1000"/>
+              </a:spcAft>
+            </a:pPr>
+            <a:r>
+              <a:rPr sz="1900" b="1">
+                <a:solidFill>
+                  <a:srgbClr val="0F2540"/>
+                </a:solidFill>
+              </a:rPr>
+              <a:t>▸ Double seat booking  </a:t>
+            </a:r>
+            <a:r>
+              <a:rPr sz="1900">
+                <a:solidFill>
+                  <a:srgbClr val="222222"/>
+                </a:solidFill>
+              </a:rPr>
+              <a:t>UNIQUE(departure, seat) refuses it in storage.</a:t>
+            </a:r>
+          </a:p>
+          <a:p>
+            <a:pPr>
+              <a:spcAft>
+                <a:spcPts val="1000"/>
+              </a:spcAft>
+            </a:pPr>
+            <a:r>
+              <a:rPr sz="1900" b="1">
+                <a:solidFill>
+                  <a:srgbClr val="0F2540"/>
+                </a:solidFill>
+              </a:rPr>
+              <a:t>▸ Gate clash  </a:t>
+            </a:r>
+            <a:r>
+              <a:rPr sz="1900">
+                <a:solidFill>
+                  <a:srgbClr val="222222"/>
+                </a:solidFill>
+              </a:rPr>
+              <a:t>UNIQUE(terminal, gate) — one gate, one row.</a:t>
+            </a:r>
+          </a:p>
+          <a:p>
+            <a:pPr>
+              <a:spcAft>
+                <a:spcPts val="1000"/>
+              </a:spcAft>
+            </a:pPr>
+            <a:r>
+              <a:rPr sz="1900" b="1">
+                <a:solidFill>
+                  <a:srgbClr val="0F2540"/>
+                </a:solidFill>
+              </a:rPr>
+              <a:t>▸ Wrong baggage fee  </a:t>
+            </a:r>
+            <a:r>
+              <a:rPr sz="1900">
+                <a:solidFill>
+                  <a:srgbClr val="222222"/>
+                </a:solidFill>
+              </a:rPr>
+              <a:t>one fee rule in booking_receipt_view: 20 kg free, Rs 500/kg.</a:t>
+            </a:r>
+          </a:p>
+          <a:p>
+            <a:pPr>
+              <a:spcAft>
+                <a:spcPts val="1000"/>
+              </a:spcAft>
+            </a:pPr>
+            <a:r>
+              <a:rPr sz="1900" b="1">
+                <a:solidFill>
+                  <a:srgbClr val="0F2540"/>
+                </a:solidFill>
+              </a:rPr>
+              <a:t>▸ No shared database  </a:t>
+            </a:r>
+            <a:r>
+              <a:rPr sz="1900">
+                <a:solidFill>
+                  <a:srgbClr val="222222"/>
+                </a:solidFill>
+              </a:rPr>
+              <a:t>one skyroute_db for all five airports.</a:t>
+            </a:r>
+          </a:p>
+          <a:p>
+            <a:pPr>
+              <a:spcAft>
+                <a:spcPts val="1000"/>
+              </a:spcAft>
+            </a:pPr>
+            <a:r>
+              <a:rPr sz="1900" b="1">
+                <a:solidFill>
+                  <a:srgbClr val="0F2540"/>
+                </a:solidFill>
+              </a:rPr>
+              <a:t>▸ Overselling  </a:t>
+            </a:r>
+            <a:r>
+              <a:rPr sz="1900">
+                <a:solidFill>
+                  <a:srgbClr val="222222"/>
+                </a:solidFill>
+              </a:rPr>
+              <a:t>trigger refuses sales past aircraft capacity.</a:t>
             </a:r>
           </a:p>
         </p:txBody>
@@ -3471,14 +4069,57 @@
       <p:grpSpPr/>
       <p:sp>
         <p:nvSpPr>
-          <p:cNvPr id="2" name="TextBox 1"/>
+          <p:cNvPr id="2" name="Rectangle 1"/>
+          <p:cNvSpPr/>
+          <p:nvPr/>
+        </p:nvSpPr>
+        <p:spPr>
+          <a:xfrm>
+            <a:off x="0" y="0"/>
+            <a:ext cx="12192000" cy="1651000"/>
+          </a:xfrm>
+          <a:prstGeom prst="rect">
+            <a:avLst/>
+          </a:prstGeom>
+          <a:solidFill>
+            <a:srgbClr val="0F2540"/>
+          </a:solidFill>
+          <a:ln>
+            <a:noFill/>
+          </a:ln>
+        </p:spPr>
+        <p:style>
+          <a:lnRef idx="1">
+            <a:schemeClr val="accent1"/>
+          </a:lnRef>
+          <a:fillRef idx="3">
+            <a:schemeClr val="accent1"/>
+          </a:fillRef>
+          <a:effectRef idx="2">
+            <a:schemeClr val="accent1"/>
+          </a:effectRef>
+          <a:fontRef idx="minor">
+            <a:schemeClr val="lt1"/>
+          </a:fontRef>
+        </p:style>
+        <p:txBody>
+          <a:bodyPr rtlCol="0" anchor="ctr"/>
+          <a:lstStyle/>
+          <a:p>
+            <a:pPr algn="ctr"/>
+          </a:p>
+        </p:txBody>
+      </p:sp>
+      <p:sp>
+        <p:nvSpPr>
+          <p:cNvPr id="3" name="TextBox 2"/>
           <p:cNvSpPr txBox="1"/>
           <p:nvPr/>
         </p:nvSpPr>
         <p:spPr>
           <a:xfrm>
-            <a:off x="508000" y="254000"/>
-            <a:ext cx="11176000" cy="1016000"/>
+            <a:off x="609600" y="279400"/>
+            <a:ext cx="10972800" cy="381000"/>
           </a:xfrm>
           <a:prstGeom prst="rect">
             <a:avLst/>
@@ -3486,28 +4127,32 @@
           <a:noFill/>
         </p:spPr>
         <p:txBody>
-          <a:bodyPr wrap="none">
+          <a:bodyPr wrap="square">
             <a:spAutoFit/>
           </a:bodyPr>
           <a:lstStyle/>
           <a:p>
             <a:r>
-              <a:rPr sz="3200" b="1"/>
-              <a:t>ER model</a:t>
-            </a:r>
-          </a:p>
-        </p:txBody>
-      </p:sp>
-      <p:sp>
-        <p:nvSpPr>
-          <p:cNvPr id="3" name="TextBox 2"/>
+              <a:rPr sz="1300" b="1">
+                <a:solidFill>
+                  <a:srgbClr val="F5A623"/>
+                </a:solidFill>
+              </a:rPr>
+              <a:t>SKYROUTE</a:t>
+            </a:r>
+          </a:p>
+        </p:txBody>
+      </p:sp>
+      <p:sp>
+        <p:nvSpPr>
+          <p:cNvPr id="4" name="TextBox 3"/>
           <p:cNvSpPr txBox="1"/>
           <p:nvPr/>
         </p:nvSpPr>
         <p:spPr>
           <a:xfrm>
-            <a:off x="508000" y="1524000"/>
-            <a:ext cx="11176000" cy="4826000"/>
+            <a:off x="609600" y="609600"/>
+            <a:ext cx="10972800" cy="889000"/>
           </a:xfrm>
           <a:prstGeom prst="rect">
             <a:avLst/>
@@ -3520,31 +4165,161 @@
           </a:bodyPr>
           <a:lstStyle/>
           <a:p>
-            <a:pPr/>
-            <a:r>
-              <a:rPr sz="2000"/>
-              <a:t>•  Masters: Airport, Airline, Aircraft, Terminal/Gate/Runway</a:t>
-            </a:r>
-          </a:p>
-          <a:p>
-            <a:pPr/>
-            <a:r>
-              <a:rPr sz="2000"/>
-              <a:t>•  Flight (timetable) 1—N Flight_Instance (dated departure)</a:t>
-            </a:r>
-          </a:p>
-          <a:p>
-            <a:pPr/>
-            <a:r>
-              <a:rPr sz="2000"/>
-              <a:t>•  Passenger 1—N Booking N—1 Instance; Baggage weak entity</a:t>
-            </a:r>
-          </a:p>
-          <a:p>
-            <a:pPr/>
-            <a:r>
-              <a:rPr sz="2000"/>
-              <a:t>•  Employee supertype with Pilot / Crew / Ground subtypes</a:t>
+            <a:r>
+              <a:rPr sz="3000" b="1">
+                <a:solidFill>
+                  <a:srgbClr val="FFFFFF"/>
+                </a:solidFill>
+              </a:rPr>
+              <a:t>ER model: timetable vs dated reality</a:t>
+            </a:r>
+          </a:p>
+        </p:txBody>
+      </p:sp>
+      <p:sp>
+        <p:nvSpPr>
+          <p:cNvPr id="5" name="TextBox 4"/>
+          <p:cNvSpPr txBox="1"/>
+          <p:nvPr/>
+        </p:nvSpPr>
+        <p:spPr>
+          <a:xfrm>
+            <a:off x="609600" y="6350000"/>
+            <a:ext cx="10972800" cy="304800"/>
+          </a:xfrm>
+          <a:prstGeom prst="rect">
+            <a:avLst/>
+          </a:prstGeom>
+          <a:noFill/>
+        </p:spPr>
+        <p:txBody>
+          <a:bodyPr wrap="square">
+            <a:spAutoFit/>
+          </a:bodyPr>
+          <a:lstStyle/>
+          <a:p>
+            <a:r>
+              <a:rPr sz="1100">
+                <a:solidFill>
+                  <a:srgbClr val="5B6B7F"/>
+                </a:solidFill>
+              </a:rPr>
+              <a:t>SkyRoute  ·  DBMS mini project  ·  skyroute_db (MySQL 8.0)</a:t>
+            </a:r>
+          </a:p>
+        </p:txBody>
+      </p:sp>
+      <p:sp>
+        <p:nvSpPr>
+          <p:cNvPr id="6" name="TextBox 5"/>
+          <p:cNvSpPr txBox="1"/>
+          <p:nvPr/>
+        </p:nvSpPr>
+        <p:spPr>
+          <a:xfrm>
+            <a:off x="609600" y="1905000"/>
+            <a:ext cx="10972800" cy="4191000"/>
+          </a:xfrm>
+          <a:prstGeom prst="rect">
+            <a:avLst/>
+          </a:prstGeom>
+          <a:noFill/>
+        </p:spPr>
+        <p:txBody>
+          <a:bodyPr wrap="square">
+            <a:spAutoFit/>
+          </a:bodyPr>
+          <a:lstStyle/>
+          <a:p>
+            <a:pPr>
+              <a:spcAft>
+                <a:spcPts val="1000"/>
+              </a:spcAft>
+            </a:pPr>
+            <a:r>
+              <a:rPr sz="1900" b="1">
+                <a:solidFill>
+                  <a:srgbClr val="0F2540"/>
+                </a:solidFill>
+              </a:rPr>
+              <a:t>▸ Masters  </a:t>
+            </a:r>
+            <a:r>
+              <a:rPr sz="1900">
+                <a:solidFill>
+                  <a:srgbClr val="222222"/>
+                </a:solidFill>
+              </a:rPr>
+              <a:t>Airport, Airline, Aircraft, Terminal, Gate.</a:t>
+            </a:r>
+          </a:p>
+          <a:p>
+            <a:pPr>
+              <a:spcAft>
+                <a:spcPts val="1000"/>
+              </a:spcAft>
+            </a:pPr>
+            <a:r>
+              <a:rPr sz="1900" b="1">
+                <a:solidFill>
+                  <a:srgbClr val="0F2540"/>
+                </a:solidFill>
+              </a:rPr>
+              <a:t>▸ Flight → Departures  </a:t>
+            </a:r>
+            <a:r>
+              <a:rPr sz="1900">
+                <a:solidFill>
+                  <a:srgbClr val="222222"/>
+                </a:solidFill>
+              </a:rPr>
+              <a:t>timetable template owns unlimited dated departures.</a:t>
+            </a:r>
+          </a:p>
+          <a:p>
+            <a:pPr>
+              <a:spcAft>
+                <a:spcPts val="1000"/>
+              </a:spcAft>
+            </a:pPr>
+            <a:r>
+              <a:rPr sz="1900" b="1">
+                <a:solidFill>
+                  <a:srgbClr val="0F2540"/>
+                </a:solidFill>
+              </a:rPr>
+              <a:t>▸ Booking bridge  </a:t>
+            </a:r>
+            <a:r>
+              <a:rPr sz="1900">
+                <a:solidFill>
+                  <a:srgbClr val="222222"/>
+                </a:solidFill>
+              </a:rPr>
+              <a:t>passengers meet departures; bags hang off bookings (weak).</a:t>
+            </a:r>
+          </a:p>
+          <a:p>
+            <a:pPr>
+              <a:spcAft>
+                <a:spcPts val="1000"/>
+              </a:spcAft>
+            </a:pPr>
+            <a:r>
+              <a:rPr sz="1900" b="1">
+                <a:solidFill>
+                  <a:srgbClr val="0F2540"/>
+                </a:solidFill>
+              </a:rPr>
+              <a:t>▸ Staff  </a:t>
+            </a:r>
+            <a:r>
+              <a:rPr sz="1900">
+                <a:solidFill>
+                  <a:srgbClr val="222222"/>
+                </a:solidFill>
+              </a:rPr>
+              <a:t>Employee supertype + Pilot / Crew / Ground subtypes.</a:t>
             </a:r>
           </a:p>
         </p:txBody>
@@ -3569,14 +4344,57 @@
       <p:grpSpPr/>
       <p:sp>
         <p:nvSpPr>
-          <p:cNvPr id="2" name="TextBox 1"/>
+          <p:cNvPr id="2" name="Rectangle 1"/>
+          <p:cNvSpPr/>
+          <p:nvPr/>
+        </p:nvSpPr>
+        <p:spPr>
+          <a:xfrm>
+            <a:off x="0" y="0"/>
+            <a:ext cx="12192000" cy="1651000"/>
+          </a:xfrm>
+          <a:prstGeom prst="rect">
+            <a:avLst/>
+          </a:prstGeom>
+          <a:solidFill>
+            <a:srgbClr val="0F2540"/>
+          </a:solidFill>
+          <a:ln>
+            <a:noFill/>
+          </a:ln>
+        </p:spPr>
+        <p:style>
+          <a:lnRef idx="1">
+            <a:schemeClr val="accent1"/>
+          </a:lnRef>
+          <a:fillRef idx="3">
+            <a:schemeClr val="accent1"/>
+          </a:fillRef>
+          <a:effectRef idx="2">
+            <a:schemeClr val="accent1"/>
+          </a:effectRef>
+          <a:fontRef idx="minor">
+            <a:schemeClr val="lt1"/>
+          </a:fontRef>
+        </p:style>
+        <p:txBody>
+          <a:bodyPr rtlCol="0" anchor="ctr"/>
+          <a:lstStyle/>
+          <a:p>
+            <a:pPr algn="ctr"/>
+          </a:p>
+        </p:txBody>
+      </p:sp>
+      <p:sp>
+        <p:nvSpPr>
+          <p:cNvPr id="3" name="TextBox 2"/>
           <p:cNvSpPr txBox="1"/>
           <p:nvPr/>
         </p:nvSpPr>
         <p:spPr>
           <a:xfrm>
-            <a:off x="508000" y="254000"/>
-            <a:ext cx="11176000" cy="1016000"/>
+            <a:off x="609600" y="279400"/>
+            <a:ext cx="10972800" cy="381000"/>
           </a:xfrm>
           <a:prstGeom prst="rect">
             <a:avLst/>
@@ -3584,28 +4402,32 @@
           <a:noFill/>
         </p:spPr>
         <p:txBody>
-          <a:bodyPr wrap="none">
+          <a:bodyPr wrap="square">
             <a:spAutoFit/>
           </a:bodyPr>
           <a:lstStyle/>
           <a:p>
             <a:r>
-              <a:rPr sz="3200" b="1"/>
-              <a:t>Schema highlights</a:t>
-            </a:r>
-          </a:p>
-        </p:txBody>
-      </p:sp>
-      <p:sp>
-        <p:nvSpPr>
-          <p:cNvPr id="3" name="TextBox 2"/>
+              <a:rPr sz="1300" b="1">
+                <a:solidFill>
+                  <a:srgbClr val="F5A623"/>
+                </a:solidFill>
+              </a:rPr>
+              <a:t>SKYROUTE</a:t>
+            </a:r>
+          </a:p>
+        </p:txBody>
+      </p:sp>
+      <p:sp>
+        <p:nvSpPr>
+          <p:cNvPr id="4" name="TextBox 3"/>
           <p:cNvSpPr txBox="1"/>
           <p:nvPr/>
         </p:nvSpPr>
         <p:spPr>
           <a:xfrm>
-            <a:off x="508000" y="1524000"/>
-            <a:ext cx="11176000" cy="4826000"/>
+            <a:off x="609600" y="609600"/>
+            <a:ext cx="10972800" cy="889000"/>
           </a:xfrm>
           <a:prstGeom prst="rect">
             <a:avLst/>
@@ -3618,35 +4440,496 @@
           </a:bodyPr>
           <a:lstStyle/>
           <a:p>
-            <a:pPr/>
-            <a:r>
-              <a:rPr sz="2000"/>
-              <a:t>•  18 InnoDB tables, surrogate integer PKs, business UNIQUE keys</a:t>
-            </a:r>
-          </a:p>
-          <a:p>
-            <a:pPr/>
-            <a:r>
-              <a:rPr sz="2000"/>
-              <a:t>•  Flights carry departure AND arrival airports, CHECK dep &lt;&gt; arr</a:t>
-            </a:r>
-          </a:p>
-          <a:p>
-            <a:pPr/>
-            <a:r>
-              <a:rPr sz="2000"/>
-              <a:t>•  UNIQUE(instance, seat): double booking impossible in storage</a:t>
-            </a:r>
-          </a:p>
-          <a:p>
-            <a:pPr/>
-            <a:r>
-              <a:rPr sz="2000"/>
-              <a:t>•  UNIQUE(terminal, gate): gate clash impossible in storage</a:t>
-            </a:r>
-          </a:p>
-        </p:txBody>
-      </p:sp>
+            <a:r>
+              <a:rPr sz="3000" b="1">
+                <a:solidFill>
+                  <a:srgbClr val="FFFFFF"/>
+                </a:solidFill>
+              </a:rPr>
+              <a:t>Schema: 16 tables, every key earns its place</a:t>
+            </a:r>
+          </a:p>
+        </p:txBody>
+      </p:sp>
+      <p:sp>
+        <p:nvSpPr>
+          <p:cNvPr id="5" name="TextBox 4"/>
+          <p:cNvSpPr txBox="1"/>
+          <p:nvPr/>
+        </p:nvSpPr>
+        <p:spPr>
+          <a:xfrm>
+            <a:off x="609600" y="6350000"/>
+            <a:ext cx="10972800" cy="304800"/>
+          </a:xfrm>
+          <a:prstGeom prst="rect">
+            <a:avLst/>
+          </a:prstGeom>
+          <a:noFill/>
+        </p:spPr>
+        <p:txBody>
+          <a:bodyPr wrap="square">
+            <a:spAutoFit/>
+          </a:bodyPr>
+          <a:lstStyle/>
+          <a:p>
+            <a:r>
+              <a:rPr sz="1100">
+                <a:solidFill>
+                  <a:srgbClr val="5B6B7F"/>
+                </a:solidFill>
+              </a:rPr>
+              <a:t>SkyRoute  ·  DBMS mini project  ·  skyroute_db (MySQL 8.0)</a:t>
+            </a:r>
+          </a:p>
+        </p:txBody>
+      </p:sp>
+      <p:graphicFrame>
+        <p:nvGraphicFramePr>
+          <p:cNvPr id="6" name="Table 5"/>
+          <p:cNvGraphicFramePr>
+            <a:graphicFrameLocks noGrp="1"/>
+          </p:cNvGraphicFramePr>
+          <p:nvPr/>
+        </p:nvGraphicFramePr>
+        <p:xfrm>
+          <a:off x="609600" y="1905000"/>
+          <a:ext cx="10972800" cy="4064000"/>
+        </p:xfrm>
+        <a:graphic>
+          <a:graphicData uri="http://schemas.openxmlformats.org/drawingml/2006/table">
+            <a:tbl>
+              <a:tblPr firstRow="1" bandRow="1">
+                <a:tableStyleId>{5C22544A-7EE6-4342-B048-85BDC9FD1C3A}</a:tableStyleId>
+              </a:tblPr>
+              <a:tblGrid>
+                <a:gridCol w="2540000"/>
+                <a:gridCol w="2286000"/>
+                <a:gridCol w="6146800"/>
+              </a:tblGrid>
+              <a:tr h="580571">
+                <a:tc>
+                  <a:txBody>
+                    <a:bodyPr/>
+                    <a:lstStyle/>
+                    <a:p>
+                      <a:r>
+                        <a:rPr sz="1500" b="1">
+                          <a:solidFill>
+                            <a:srgbClr val="FFFFFF"/>
+                          </a:solidFill>
+                        </a:rPr>
+                        <a:t>Table</a:t>
+                      </a:r>
+                    </a:p>
+                  </a:txBody>
+                  <a:tcPr>
+                    <a:solidFill>
+                      <a:srgbClr val="0F2540"/>
+                    </a:solidFill>
+                  </a:tcPr>
+                </a:tc>
+                <a:tc>
+                  <a:txBody>
+                    <a:bodyPr/>
+                    <a:lstStyle/>
+                    <a:p>
+                      <a:r>
+                        <a:rPr sz="1500" b="1">
+                          <a:solidFill>
+                            <a:srgbClr val="FFFFFF"/>
+                          </a:solidFill>
+                        </a:rPr>
+                        <a:t>Primary key</a:t>
+                      </a:r>
+                    </a:p>
+                  </a:txBody>
+                  <a:tcPr>
+                    <a:solidFill>
+                      <a:srgbClr val="0F2540"/>
+                    </a:solidFill>
+                  </a:tcPr>
+                </a:tc>
+                <a:tc>
+                  <a:txBody>
+                    <a:bodyPr/>
+                    <a:lstStyle/>
+                    <a:p>
+                      <a:r>
+                        <a:rPr sz="1500" b="1">
+                          <a:solidFill>
+                            <a:srgbClr val="FFFFFF"/>
+                          </a:solidFill>
+                        </a:rPr>
+                        <a:t>Rule that matters</a:t>
+                      </a:r>
+                    </a:p>
+                  </a:txBody>
+                  <a:tcPr>
+                    <a:solidFill>
+                      <a:srgbClr val="0F2540"/>
+                    </a:solidFill>
+                  </a:tcPr>
+                </a:tc>
+              </a:tr>
+              <a:tr h="580571">
+                <a:tc>
+                  <a:txBody>
+                    <a:bodyPr/>
+                    <a:lstStyle/>
+                    <a:p>
+                      <a:r>
+                        <a:rPr sz="1400">
+                          <a:solidFill>
+                            <a:srgbClr val="222222"/>
+                          </a:solidFill>
+                        </a:rPr>
+                        <a:t>Flights</a:t>
+                      </a:r>
+                    </a:p>
+                  </a:txBody>
+                  <a:tcPr/>
+                </a:tc>
+                <a:tc>
+                  <a:txBody>
+                    <a:bodyPr/>
+                    <a:lstStyle/>
+                    <a:p>
+                      <a:r>
+                        <a:rPr sz="1400">
+                          <a:solidFill>
+                            <a:srgbClr val="222222"/>
+                          </a:solidFill>
+                        </a:rPr>
+                        <a:t>flight_id</a:t>
+                      </a:r>
+                    </a:p>
+                  </a:txBody>
+                  <a:tcPr/>
+                </a:tc>
+                <a:tc>
+                  <a:txBody>
+                    <a:bodyPr/>
+                    <a:lstStyle/>
+                    <a:p>
+                      <a:r>
+                        <a:rPr sz="1400">
+                          <a:solidFill>
+                            <a:srgbClr val="222222"/>
+                          </a:solidFill>
+                        </a:rPr>
+                        <a:t>UNIQUE number · dep ≠ arr airports</a:t>
+                      </a:r>
+                    </a:p>
+                  </a:txBody>
+                  <a:tcPr/>
+                </a:tc>
+              </a:tr>
+              <a:tr h="580571">
+                <a:tc>
+                  <a:txBody>
+                    <a:bodyPr/>
+                    <a:lstStyle/>
+                    <a:p>
+                      <a:r>
+                        <a:rPr sz="1400">
+                          <a:solidFill>
+                            <a:srgbClr val="222222"/>
+                          </a:solidFill>
+                        </a:rPr>
+                        <a:t>Departures</a:t>
+                      </a:r>
+                    </a:p>
+                  </a:txBody>
+                  <a:tcPr>
+                    <a:solidFill>
+                      <a:srgbClr val="F6F8FB"/>
+                    </a:solidFill>
+                  </a:tcPr>
+                </a:tc>
+                <a:tc>
+                  <a:txBody>
+                    <a:bodyPr/>
+                    <a:lstStyle/>
+                    <a:p>
+                      <a:r>
+                        <a:rPr sz="1400">
+                          <a:solidFill>
+                            <a:srgbClr val="222222"/>
+                          </a:solidFill>
+                        </a:rPr>
+                        <a:t>departure_id</a:t>
+                      </a:r>
+                    </a:p>
+                  </a:txBody>
+                  <a:tcPr>
+                    <a:solidFill>
+                      <a:srgbClr val="F6F8FB"/>
+                    </a:solidFill>
+                  </a:tcPr>
+                </a:tc>
+                <a:tc>
+                  <a:txBody>
+                    <a:bodyPr/>
+                    <a:lstStyle/>
+                    <a:p>
+                      <a:r>
+                        <a:rPr sz="1400">
+                          <a:solidFill>
+                            <a:srgbClr val="222222"/>
+                          </a:solidFill>
+                        </a:rPr>
+                        <a:t>UNIQUE(flight, date-time)</a:t>
+                      </a:r>
+                    </a:p>
+                  </a:txBody>
+                  <a:tcPr>
+                    <a:solidFill>
+                      <a:srgbClr val="F6F8FB"/>
+                    </a:solidFill>
+                  </a:tcPr>
+                </a:tc>
+              </a:tr>
+              <a:tr h="580571">
+                <a:tc>
+                  <a:txBody>
+                    <a:bodyPr/>
+                    <a:lstStyle/>
+                    <a:p>
+                      <a:r>
+                        <a:rPr sz="1400">
+                          <a:solidFill>
+                            <a:srgbClr val="222222"/>
+                          </a:solidFill>
+                        </a:rPr>
+                        <a:t>Bookings</a:t>
+                      </a:r>
+                    </a:p>
+                  </a:txBody>
+                  <a:tcPr/>
+                </a:tc>
+                <a:tc>
+                  <a:txBody>
+                    <a:bodyPr/>
+                    <a:lstStyle/>
+                    <a:p>
+                      <a:r>
+                        <a:rPr sz="1400">
+                          <a:solidFill>
+                            <a:srgbClr val="222222"/>
+                          </a:solidFill>
+                        </a:rPr>
+                        <a:t>booking_id</a:t>
+                      </a:r>
+                    </a:p>
+                  </a:txBody>
+                  <a:tcPr/>
+                </a:tc>
+                <a:tc>
+                  <a:txBody>
+                    <a:bodyPr/>
+                    <a:lstStyle/>
+                    <a:p>
+                      <a:r>
+                        <a:rPr sz="1400">
+                          <a:solidFill>
+                            <a:srgbClr val="222222"/>
+                          </a:solidFill>
+                        </a:rPr>
+                        <a:t>UNIQUE(departure, seat)</a:t>
+                      </a:r>
+                    </a:p>
+                  </a:txBody>
+                  <a:tcPr/>
+                </a:tc>
+              </a:tr>
+              <a:tr h="580571">
+                <a:tc>
+                  <a:txBody>
+                    <a:bodyPr/>
+                    <a:lstStyle/>
+                    <a:p>
+                      <a:r>
+                        <a:rPr sz="1400">
+                          <a:solidFill>
+                            <a:srgbClr val="222222"/>
+                          </a:solidFill>
+                        </a:rPr>
+                        <a:t>Baggage</a:t>
+                      </a:r>
+                    </a:p>
+                  </a:txBody>
+                  <a:tcPr>
+                    <a:solidFill>
+                      <a:srgbClr val="F6F8FB"/>
+                    </a:solidFill>
+                  </a:tcPr>
+                </a:tc>
+                <a:tc>
+                  <a:txBody>
+                    <a:bodyPr/>
+                    <a:lstStyle/>
+                    <a:p>
+                      <a:r>
+                        <a:rPr sz="1400">
+                          <a:solidFill>
+                            <a:srgbClr val="222222"/>
+                          </a:solidFill>
+                        </a:rPr>
+                        <a:t>(booking, seq)</a:t>
+                      </a:r>
+                    </a:p>
+                  </a:txBody>
+                  <a:tcPr>
+                    <a:solidFill>
+                      <a:srgbClr val="F6F8FB"/>
+                    </a:solidFill>
+                  </a:tcPr>
+                </a:tc>
+                <a:tc>
+                  <a:txBody>
+                    <a:bodyPr/>
+                    <a:lstStyle/>
+                    <a:p>
+                      <a:r>
+                        <a:rPr sz="1400">
+                          <a:solidFill>
+                            <a:srgbClr val="222222"/>
+                          </a:solidFill>
+                        </a:rPr>
+                        <a:t>weak entity · 0 &lt; kg ≤ 100</a:t>
+                      </a:r>
+                    </a:p>
+                  </a:txBody>
+                  <a:tcPr>
+                    <a:solidFill>
+                      <a:srgbClr val="F6F8FB"/>
+                    </a:solidFill>
+                  </a:tcPr>
+                </a:tc>
+              </a:tr>
+              <a:tr h="580571">
+                <a:tc>
+                  <a:txBody>
+                    <a:bodyPr/>
+                    <a:lstStyle/>
+                    <a:p>
+                      <a:r>
+                        <a:rPr sz="1400">
+                          <a:solidFill>
+                            <a:srgbClr val="222222"/>
+                          </a:solidFill>
+                        </a:rPr>
+                        <a:t>Gates</a:t>
+                      </a:r>
+                    </a:p>
+                  </a:txBody>
+                  <a:tcPr/>
+                </a:tc>
+                <a:tc>
+                  <a:txBody>
+                    <a:bodyPr/>
+                    <a:lstStyle/>
+                    <a:p>
+                      <a:r>
+                        <a:rPr sz="1400">
+                          <a:solidFill>
+                            <a:srgbClr val="222222"/>
+                          </a:solidFill>
+                        </a:rPr>
+                        <a:t>gate_id</a:t>
+                      </a:r>
+                    </a:p>
+                  </a:txBody>
+                  <a:tcPr/>
+                </a:tc>
+                <a:tc>
+                  <a:txBody>
+                    <a:bodyPr/>
+                    <a:lstStyle/>
+                    <a:p>
+                      <a:r>
+                        <a:rPr sz="1400">
+                          <a:solidFill>
+                            <a:srgbClr val="222222"/>
+                          </a:solidFill>
+                        </a:rPr>
+                        <a:t>UNIQUE(terminal, gate)</a:t>
+                      </a:r>
+                    </a:p>
+                  </a:txBody>
+                  <a:tcPr/>
+                </a:tc>
+              </a:tr>
+              <a:tr h="580574">
+                <a:tc>
+                  <a:txBody>
+                    <a:bodyPr/>
+                    <a:lstStyle/>
+                    <a:p>
+                      <a:r>
+                        <a:rPr sz="1400">
+                          <a:solidFill>
+                            <a:srgbClr val="222222"/>
+                          </a:solidFill>
+                        </a:rPr>
+                        <a:t>Payments / Check-Ins</a:t>
+                      </a:r>
+                    </a:p>
+                  </a:txBody>
+                  <a:tcPr>
+                    <a:solidFill>
+                      <a:srgbClr val="F6F8FB"/>
+                    </a:solidFill>
+                  </a:tcPr>
+                </a:tc>
+                <a:tc>
+                  <a:txBody>
+                    <a:bodyPr/>
+                    <a:lstStyle/>
+                    <a:p>
+                      <a:r>
+                        <a:rPr sz="1400">
+                          <a:solidFill>
+                            <a:srgbClr val="222222"/>
+                          </a:solidFill>
+                        </a:rPr>
+                        <a:t>own ids</a:t>
+                      </a:r>
+                    </a:p>
+                  </a:txBody>
+                  <a:tcPr>
+                    <a:solidFill>
+                      <a:srgbClr val="F6F8FB"/>
+                    </a:solidFill>
+                  </a:tcPr>
+                </a:tc>
+                <a:tc>
+                  <a:txBody>
+                    <a:bodyPr/>
+                    <a:lstStyle/>
+                    <a:p>
+                      <a:r>
+                        <a:rPr sz="1400">
+                          <a:solidFill>
+                            <a:srgbClr val="222222"/>
+                          </a:solidFill>
+                        </a:rPr>
+                        <a:t>UNIQUE booking (one-to-one)</a:t>
+                      </a:r>
+                    </a:p>
+                  </a:txBody>
+                  <a:tcPr>
+                    <a:solidFill>
+                      <a:srgbClr val="F6F8FB"/>
+                    </a:solidFill>
+                  </a:tcPr>
+                </a:tc>
+              </a:tr>
+            </a:tbl>
+          </a:graphicData>
+        </a:graphic>
+      </p:graphicFrame>
     </p:spTree>
   </p:cSld>
   <p:clrMapOvr>
@@ -3667,14 +4950,57 @@
       <p:grpSpPr/>
       <p:sp>
         <p:nvSpPr>
-          <p:cNvPr id="2" name="TextBox 1"/>
+          <p:cNvPr id="2" name="Rectangle 1"/>
+          <p:cNvSpPr/>
+          <p:nvPr/>
+        </p:nvSpPr>
+        <p:spPr>
+          <a:xfrm>
+            <a:off x="0" y="0"/>
+            <a:ext cx="12192000" cy="1651000"/>
+          </a:xfrm>
+          <a:prstGeom prst="rect">
+            <a:avLst/>
+          </a:prstGeom>
+          <a:solidFill>
+            <a:srgbClr val="0F2540"/>
+          </a:solidFill>
+          <a:ln>
+            <a:noFill/>
+          </a:ln>
+        </p:spPr>
+        <p:style>
+          <a:lnRef idx="1">
+            <a:schemeClr val="accent1"/>
+          </a:lnRef>
+          <a:fillRef idx="3">
+            <a:schemeClr val="accent1"/>
+          </a:fillRef>
+          <a:effectRef idx="2">
+            <a:schemeClr val="accent1"/>
+          </a:effectRef>
+          <a:fontRef idx="minor">
+            <a:schemeClr val="lt1"/>
+          </a:fontRef>
+        </p:style>
+        <p:txBody>
+          <a:bodyPr rtlCol="0" anchor="ctr"/>
+          <a:lstStyle/>
+          <a:p>
+            <a:pPr algn="ctr"/>
+          </a:p>
+        </p:txBody>
+      </p:sp>
+      <p:sp>
+        <p:nvSpPr>
+          <p:cNvPr id="3" name="TextBox 2"/>
           <p:cNvSpPr txBox="1"/>
           <p:nvPr/>
         </p:nvSpPr>
         <p:spPr>
           <a:xfrm>
-            <a:off x="508000" y="254000"/>
-            <a:ext cx="11176000" cy="1016000"/>
+            <a:off x="609600" y="279400"/>
+            <a:ext cx="10972800" cy="381000"/>
           </a:xfrm>
           <a:prstGeom prst="rect">
             <a:avLst/>
@@ -3682,28 +5008,32 @@
           <a:noFill/>
         </p:spPr>
         <p:txBody>
-          <a:bodyPr wrap="none">
+          <a:bodyPr wrap="square">
             <a:spAutoFit/>
           </a:bodyPr>
           <a:lstStyle/>
           <a:p>
             <a:r>
-              <a:rPr sz="3200" b="1"/>
-              <a:t>Scale by design + generator</a:t>
-            </a:r>
-          </a:p>
-        </p:txBody>
-      </p:sp>
-      <p:sp>
-        <p:nvSpPr>
-          <p:cNvPr id="3" name="TextBox 2"/>
+              <a:rPr sz="1300" b="1">
+                <a:solidFill>
+                  <a:srgbClr val="F5A623"/>
+                </a:solidFill>
+              </a:rPr>
+              <a:t>SKYROUTE</a:t>
+            </a:r>
+          </a:p>
+        </p:txBody>
+      </p:sp>
+      <p:sp>
+        <p:nvSpPr>
+          <p:cNvPr id="4" name="TextBox 3"/>
           <p:cNvSpPr txBox="1"/>
           <p:nvPr/>
         </p:nvSpPr>
         <p:spPr>
           <a:xfrm>
-            <a:off x="508000" y="1524000"/>
-            <a:ext cx="11176000" cy="4826000"/>
+            <a:off x="609600" y="609600"/>
+            <a:ext cx="10972800" cy="889000"/>
           </a:xfrm>
           <a:prstGeom prst="rect">
             <a:avLst/>
@@ -3716,31 +5046,161 @@
           </a:bodyPr>
           <a:lstStyle/>
           <a:p>
-            <a:pPr/>
-            <a:r>
-              <a:rPr sz="2000"/>
-              <a:t>•  Flight/Instance split holds unlimited dated departures</a:t>
-            </a:r>
-          </a:p>
-          <a:p>
-            <a:pPr/>
-            <a:r>
-              <a:rPr sz="2000"/>
-              <a:t>•  Deterministic generator (seed 42): 14 days, 35–80% load factors</a:t>
-            </a:r>
-          </a:p>
-          <a:p>
-            <a:pPr/>
-            <a:r>
-              <a:rPr sz="2000"/>
-              <a:t>•  Machine-verified: zero duplicate seats, all FKs in range</a:t>
-            </a:r>
-          </a:p>
-          <a:p>
-            <a:pPr/>
-            <a:r>
-              <a:rPr sz="2000"/>
-              <a:t>•  Knobs: NUM_DAYS, ROUTES, load range — volume on demand</a:t>
+            <a:r>
+              <a:rPr sz="3000" b="1">
+                <a:solidFill>
+                  <a:srgbClr val="FFFFFF"/>
+                </a:solidFill>
+              </a:rPr>
+              <a:t>Scale: designed unlimited, demonstrated at volume</a:t>
+            </a:r>
+          </a:p>
+        </p:txBody>
+      </p:sp>
+      <p:sp>
+        <p:nvSpPr>
+          <p:cNvPr id="5" name="TextBox 4"/>
+          <p:cNvSpPr txBox="1"/>
+          <p:nvPr/>
+        </p:nvSpPr>
+        <p:spPr>
+          <a:xfrm>
+            <a:off x="609600" y="6350000"/>
+            <a:ext cx="10972800" cy="304800"/>
+          </a:xfrm>
+          <a:prstGeom prst="rect">
+            <a:avLst/>
+          </a:prstGeom>
+          <a:noFill/>
+        </p:spPr>
+        <p:txBody>
+          <a:bodyPr wrap="square">
+            <a:spAutoFit/>
+          </a:bodyPr>
+          <a:lstStyle/>
+          <a:p>
+            <a:r>
+              <a:rPr sz="1100">
+                <a:solidFill>
+                  <a:srgbClr val="5B6B7F"/>
+                </a:solidFill>
+              </a:rPr>
+              <a:t>SkyRoute  ·  DBMS mini project  ·  skyroute_db (MySQL 8.0)</a:t>
+            </a:r>
+          </a:p>
+        </p:txBody>
+      </p:sp>
+      <p:sp>
+        <p:nvSpPr>
+          <p:cNvPr id="6" name="TextBox 5"/>
+          <p:cNvSpPr txBox="1"/>
+          <p:nvPr/>
+        </p:nvSpPr>
+        <p:spPr>
+          <a:xfrm>
+            <a:off x="609600" y="1905000"/>
+            <a:ext cx="10972800" cy="4191000"/>
+          </a:xfrm>
+          <a:prstGeom prst="rect">
+            <a:avLst/>
+          </a:prstGeom>
+          <a:noFill/>
+        </p:spPr>
+        <p:txBody>
+          <a:bodyPr wrap="square">
+            <a:spAutoFit/>
+          </a:bodyPr>
+          <a:lstStyle/>
+          <a:p>
+            <a:pPr>
+              <a:spcAft>
+                <a:spcPts val="1000"/>
+              </a:spcAft>
+            </a:pPr>
+            <a:r>
+              <a:rPr sz="1900" b="1">
+                <a:solidFill>
+                  <a:srgbClr val="0F2540"/>
+                </a:solidFill>
+              </a:rPr>
+              <a:t>▸ Design  </a:t>
+            </a:r>
+            <a:r>
+              <a:rPr sz="1900">
+                <a:solidFill>
+                  <a:srgbClr val="222222"/>
+                </a:solidFill>
+              </a:rPr>
+              <a:t>integer keys + indexed FKs — nothing changes at 10× volume.</a:t>
+            </a:r>
+          </a:p>
+          <a:p>
+            <a:pPr>
+              <a:spcAft>
+                <a:spcPts val="1000"/>
+              </a:spcAft>
+            </a:pPr>
+            <a:r>
+              <a:rPr sz="1900" b="1">
+                <a:solidFill>
+                  <a:srgbClr val="0F2540"/>
+                </a:solidFill>
+              </a:rPr>
+              <a:t>▸ Generator  </a:t>
+            </a:r>
+            <a:r>
+              <a:rPr sz="1900">
+                <a:solidFill>
+                  <a:srgbClr val="222222"/>
+                </a:solidFill>
+              </a:rPr>
+              <a:t>deterministic (seed 42): 14 days, 35–80% load factors.</a:t>
+            </a:r>
+          </a:p>
+          <a:p>
+            <a:pPr>
+              <a:spcAft>
+                <a:spcPts val="1000"/>
+              </a:spcAft>
+            </a:pPr>
+            <a:r>
+              <a:rPr sz="1900" b="1">
+                <a:solidFill>
+                  <a:srgbClr val="0F2540"/>
+                </a:solidFill>
+              </a:rPr>
+              <a:t>▸ Verified  </a:t>
+            </a:r>
+            <a:r>
+              <a:rPr sz="1900">
+                <a:solidFill>
+                  <a:srgbClr val="222222"/>
+                </a:solidFill>
+              </a:rPr>
+              <a:t>zero duplicate seats · all foreign keys in range.</a:t>
+            </a:r>
+          </a:p>
+          <a:p>
+            <a:pPr>
+              <a:spcAft>
+                <a:spcPts val="1000"/>
+              </a:spcAft>
+            </a:pPr>
+            <a:r>
+              <a:rPr sz="1900" b="1">
+                <a:solidFill>
+                  <a:srgbClr val="0F2540"/>
+                </a:solidFill>
+              </a:rPr>
+              <a:t>▸ Payoff  </a:t>
+            </a:r>
+            <a:r>
+              <a:rPr sz="1900">
+                <a:solidFill>
+                  <a:srgbClr val="222222"/>
+                </a:solidFill>
+              </a:rPr>
+              <a:t>load factor, revenue, gate use — one query each.</a:t>
             </a:r>
           </a:p>
         </p:txBody>
@@ -3765,14 +5225,57 @@
       <p:grpSpPr/>
       <p:sp>
         <p:nvSpPr>
-          <p:cNvPr id="2" name="TextBox 1"/>
+          <p:cNvPr id="2" name="Rectangle 1"/>
+          <p:cNvSpPr/>
+          <p:nvPr/>
+        </p:nvSpPr>
+        <p:spPr>
+          <a:xfrm>
+            <a:off x="0" y="0"/>
+            <a:ext cx="12192000" cy="1651000"/>
+          </a:xfrm>
+          <a:prstGeom prst="rect">
+            <a:avLst/>
+          </a:prstGeom>
+          <a:solidFill>
+            <a:srgbClr val="0F2540"/>
+          </a:solidFill>
+          <a:ln>
+            <a:noFill/>
+          </a:ln>
+        </p:spPr>
+        <p:style>
+          <a:lnRef idx="1">
+            <a:schemeClr val="accent1"/>
+          </a:lnRef>
+          <a:fillRef idx="3">
+            <a:schemeClr val="accent1"/>
+          </a:fillRef>
+          <a:effectRef idx="2">
+            <a:schemeClr val="accent1"/>
+          </a:effectRef>
+          <a:fontRef idx="minor">
+            <a:schemeClr val="lt1"/>
+          </a:fontRef>
+        </p:style>
+        <p:txBody>
+          <a:bodyPr rtlCol="0" anchor="ctr"/>
+          <a:lstStyle/>
+          <a:p>
+            <a:pPr algn="ctr"/>
+          </a:p>
+        </p:txBody>
+      </p:sp>
+      <p:sp>
+        <p:nvSpPr>
+          <p:cNvPr id="3" name="TextBox 2"/>
           <p:cNvSpPr txBox="1"/>
           <p:nvPr/>
         </p:nvSpPr>
         <p:spPr>
           <a:xfrm>
-            <a:off x="508000" y="254000"/>
-            <a:ext cx="11176000" cy="1016000"/>
+            <a:off x="609600" y="279400"/>
+            <a:ext cx="10972800" cy="381000"/>
           </a:xfrm>
           <a:prstGeom prst="rect">
             <a:avLst/>
@@ -3780,28 +5283,32 @@
           <a:noFill/>
         </p:spPr>
         <p:txBody>
-          <a:bodyPr wrap="none">
+          <a:bodyPr wrap="square">
             <a:spAutoFit/>
           </a:bodyPr>
           <a:lstStyle/>
           <a:p>
             <a:r>
-              <a:rPr sz="3200" b="1"/>
-              <a:t>Advanced SQL</a:t>
-            </a:r>
-          </a:p>
-        </p:txBody>
-      </p:sp>
-      <p:sp>
-        <p:nvSpPr>
-          <p:cNvPr id="3" name="TextBox 2"/>
+              <a:rPr sz="1300" b="1">
+                <a:solidFill>
+                  <a:srgbClr val="F5A623"/>
+                </a:solidFill>
+              </a:rPr>
+              <a:t>SKYROUTE</a:t>
+            </a:r>
+          </a:p>
+        </p:txBody>
+      </p:sp>
+      <p:sp>
+        <p:nvSpPr>
+          <p:cNvPr id="4" name="TextBox 3"/>
           <p:cNvSpPr txBox="1"/>
           <p:nvPr/>
         </p:nvSpPr>
         <p:spPr>
           <a:xfrm>
-            <a:off x="508000" y="1524000"/>
-            <a:ext cx="11176000" cy="4826000"/>
+            <a:off x="609600" y="609600"/>
+            <a:ext cx="10972800" cy="889000"/>
           </a:xfrm>
           <a:prstGeom prst="rect">
             <a:avLst/>
@@ -3814,31 +5321,161 @@
           </a:bodyPr>
           <a:lstStyle/>
           <a:p>
-            <a:pPr/>
-            <a:r>
-              <a:rPr sz="2000"/>
-              <a:t>•  flight_board_view: whole departure board in one query</a:t>
-            </a:r>
-          </a:p>
-          <a:p>
-            <a:pPr/>
-            <a:r>
-              <a:rPr sz="2000"/>
-              <a:t>•  booking_receipt_view: price + baggage fee (20 kg free, Rs 500/kg)</a:t>
-            </a:r>
-          </a:p>
-          <a:p>
-            <a:pPr/>
-            <a:r>
-              <a:rPr sz="2000"/>
-              <a:t>•  trg_booking_capacity: trigger refuses overselling past capacity</a:t>
-            </a:r>
-          </a:p>
-          <a:p>
-            <a:pPr/>
-            <a:r>
-              <a:rPr sz="2000"/>
-              <a:t>•  MakeBooking procedure: seat + payment atomically or not at all</a:t>
+            <a:r>
+              <a:rPr sz="3000" b="1">
+                <a:solidFill>
+                  <a:srgbClr val="FFFFFF"/>
+                </a:solidFill>
+              </a:rPr>
+              <a:t>Advanced SQL: rules live in the database</a:t>
+            </a:r>
+          </a:p>
+        </p:txBody>
+      </p:sp>
+      <p:sp>
+        <p:nvSpPr>
+          <p:cNvPr id="5" name="TextBox 4"/>
+          <p:cNvSpPr txBox="1"/>
+          <p:nvPr/>
+        </p:nvSpPr>
+        <p:spPr>
+          <a:xfrm>
+            <a:off x="609600" y="6350000"/>
+            <a:ext cx="10972800" cy="304800"/>
+          </a:xfrm>
+          <a:prstGeom prst="rect">
+            <a:avLst/>
+          </a:prstGeom>
+          <a:noFill/>
+        </p:spPr>
+        <p:txBody>
+          <a:bodyPr wrap="square">
+            <a:spAutoFit/>
+          </a:bodyPr>
+          <a:lstStyle/>
+          <a:p>
+            <a:r>
+              <a:rPr sz="1100">
+                <a:solidFill>
+                  <a:srgbClr val="5B6B7F"/>
+                </a:solidFill>
+              </a:rPr>
+              <a:t>SkyRoute  ·  DBMS mini project  ·  skyroute_db (MySQL 8.0)</a:t>
+            </a:r>
+          </a:p>
+        </p:txBody>
+      </p:sp>
+      <p:sp>
+        <p:nvSpPr>
+          <p:cNvPr id="6" name="TextBox 5"/>
+          <p:cNvSpPr txBox="1"/>
+          <p:nvPr/>
+        </p:nvSpPr>
+        <p:spPr>
+          <a:xfrm>
+            <a:off x="609600" y="1905000"/>
+            <a:ext cx="10972800" cy="4191000"/>
+          </a:xfrm>
+          <a:prstGeom prst="rect">
+            <a:avLst/>
+          </a:prstGeom>
+          <a:noFill/>
+        </p:spPr>
+        <p:txBody>
+          <a:bodyPr wrap="square">
+            <a:spAutoFit/>
+          </a:bodyPr>
+          <a:lstStyle/>
+          <a:p>
+            <a:pPr>
+              <a:spcAft>
+                <a:spcPts val="1000"/>
+              </a:spcAft>
+            </a:pPr>
+            <a:r>
+              <a:rPr sz="1900" b="1">
+                <a:solidFill>
+                  <a:srgbClr val="0F2540"/>
+                </a:solidFill>
+              </a:rPr>
+              <a:t>▸ flight_board_view  </a:t>
+            </a:r>
+            <a:r>
+              <a:rPr sz="1900">
+                <a:solidFill>
+                  <a:srgbClr val="222222"/>
+                </a:solidFill>
+              </a:rPr>
+              <a:t>the whole departure board in one query.</a:t>
+            </a:r>
+          </a:p>
+          <a:p>
+            <a:pPr>
+              <a:spcAft>
+                <a:spcPts val="1000"/>
+              </a:spcAft>
+            </a:pPr>
+            <a:r>
+              <a:rPr sz="1900" b="1">
+                <a:solidFill>
+                  <a:srgbClr val="0F2540"/>
+                </a:solidFill>
+              </a:rPr>
+              <a:t>▸ booking_receipt_view  </a:t>
+            </a:r>
+            <a:r>
+              <a:rPr sz="1900">
+                <a:solidFill>
+                  <a:srgbClr val="222222"/>
+                </a:solidFill>
+              </a:rPr>
+              <a:t>price + computed baggage fee per booking.</a:t>
+            </a:r>
+          </a:p>
+          <a:p>
+            <a:pPr>
+              <a:spcAft>
+                <a:spcPts val="1000"/>
+              </a:spcAft>
+            </a:pPr>
+            <a:r>
+              <a:rPr sz="1900" b="1">
+                <a:solidFill>
+                  <a:srgbClr val="0F2540"/>
+                </a:solidFill>
+              </a:rPr>
+              <a:t>▸ trg_booking_capacity  </a:t>
+            </a:r>
+            <a:r>
+              <a:rPr sz="1900">
+                <a:solidFill>
+                  <a:srgbClr val="222222"/>
+                </a:solidFill>
+              </a:rPr>
+              <a:t>BEFORE INSERT trigger: full flight? refused (SQLSTATE 45000).</a:t>
+            </a:r>
+          </a:p>
+          <a:p>
+            <a:pPr>
+              <a:spcAft>
+                <a:spcPts val="1000"/>
+              </a:spcAft>
+            </a:pPr>
+            <a:r>
+              <a:rPr sz="1900" b="1">
+                <a:solidFill>
+                  <a:srgbClr val="0F2540"/>
+                </a:solidFill>
+              </a:rPr>
+              <a:t>▸ MakeBooking  </a:t>
+            </a:r>
+            <a:r>
+              <a:rPr sz="1900">
+                <a:solidFill>
+                  <a:srgbClr val="222222"/>
+                </a:solidFill>
+              </a:rPr>
+              <a:t>seat + payment in one transaction — both or neither.</a:t>
             </a:r>
           </a:p>
         </p:txBody>
@@ -3863,14 +5500,57 @@
       <p:grpSpPr/>
       <p:sp>
         <p:nvSpPr>
-          <p:cNvPr id="2" name="TextBox 1"/>
+          <p:cNvPr id="2" name="Rectangle 1"/>
+          <p:cNvSpPr/>
+          <p:nvPr/>
+        </p:nvSpPr>
+        <p:spPr>
+          <a:xfrm>
+            <a:off x="0" y="0"/>
+            <a:ext cx="12192000" cy="1651000"/>
+          </a:xfrm>
+          <a:prstGeom prst="rect">
+            <a:avLst/>
+          </a:prstGeom>
+          <a:solidFill>
+            <a:srgbClr val="0F2540"/>
+          </a:solidFill>
+          <a:ln>
+            <a:noFill/>
+          </a:ln>
+        </p:spPr>
+        <p:style>
+          <a:lnRef idx="1">
+            <a:schemeClr val="accent1"/>
+          </a:lnRef>
+          <a:fillRef idx="3">
+            <a:schemeClr val="accent1"/>
+          </a:fillRef>
+          <a:effectRef idx="2">
+            <a:schemeClr val="accent1"/>
+          </a:effectRef>
+          <a:fontRef idx="minor">
+            <a:schemeClr val="lt1"/>
+          </a:fontRef>
+        </p:style>
+        <p:txBody>
+          <a:bodyPr rtlCol="0" anchor="ctr"/>
+          <a:lstStyle/>
+          <a:p>
+            <a:pPr algn="ctr"/>
+          </a:p>
+        </p:txBody>
+      </p:sp>
+      <p:sp>
+        <p:nvSpPr>
+          <p:cNvPr id="3" name="TextBox 2"/>
           <p:cNvSpPr txBox="1"/>
           <p:nvPr/>
         </p:nvSpPr>
         <p:spPr>
           <a:xfrm>
-            <a:off x="508000" y="254000"/>
-            <a:ext cx="11176000" cy="1016000"/>
+            <a:off x="609600" y="279400"/>
+            <a:ext cx="10972800" cy="381000"/>
           </a:xfrm>
           <a:prstGeom prst="rect">
             <a:avLst/>
@@ -3878,28 +5558,32 @@
           <a:noFill/>
         </p:spPr>
         <p:txBody>
-          <a:bodyPr wrap="none">
+          <a:bodyPr wrap="square">
             <a:spAutoFit/>
           </a:bodyPr>
           <a:lstStyle/>
           <a:p>
             <a:r>
-              <a:rPr sz="3200" b="1"/>
-              <a:t>Transactions (ACID, demonstrated live)</a:t>
-            </a:r>
-          </a:p>
-        </p:txBody>
-      </p:sp>
-      <p:sp>
-        <p:nvSpPr>
-          <p:cNvPr id="3" name="TextBox 2"/>
+              <a:rPr sz="1300" b="1">
+                <a:solidFill>
+                  <a:srgbClr val="F5A623"/>
+                </a:solidFill>
+              </a:rPr>
+              <a:t>SKYROUTE</a:t>
+            </a:r>
+          </a:p>
+        </p:txBody>
+      </p:sp>
+      <p:sp>
+        <p:nvSpPr>
+          <p:cNvPr id="4" name="TextBox 3"/>
           <p:cNvSpPr txBox="1"/>
           <p:nvPr/>
         </p:nvSpPr>
         <p:spPr>
           <a:xfrm>
-            <a:off x="508000" y="1524000"/>
-            <a:ext cx="11176000" cy="4826000"/>
+            <a:off x="609600" y="609600"/>
+            <a:ext cx="10972800" cy="889000"/>
           </a:xfrm>
           <a:prstGeom prst="rect">
             <a:avLst/>
@@ -3912,24 +5596,138 @@
           </a:bodyPr>
           <a:lstStyle/>
           <a:p>
-            <a:pPr/>
-            <a:r>
-              <a:rPr sz="2000"/>
-              <a:t>•  Demo A: booking + payment commit together</a:t>
-            </a:r>
-          </a:p>
-          <a:p>
-            <a:pPr/>
-            <a:r>
-              <a:rPr sz="2000"/>
-              <a:t>•  Demo B: failed payment rolls the booking back, seat stays free</a:t>
-            </a:r>
-          </a:p>
-          <a:p>
-            <a:pPr/>
-            <a:r>
-              <a:rPr sz="2000"/>
-              <a:t>•  Demo C: two sessions show REPEATABLE READ isolation</a:t>
+            <a:r>
+              <a:rPr sz="3000" b="1">
+                <a:solidFill>
+                  <a:srgbClr val="FFFFFF"/>
+                </a:solidFill>
+              </a:rPr>
+              <a:t>Transactions: ACID you can watch</a:t>
+            </a:r>
+          </a:p>
+        </p:txBody>
+      </p:sp>
+      <p:sp>
+        <p:nvSpPr>
+          <p:cNvPr id="5" name="TextBox 4"/>
+          <p:cNvSpPr txBox="1"/>
+          <p:nvPr/>
+        </p:nvSpPr>
+        <p:spPr>
+          <a:xfrm>
+            <a:off x="609600" y="6350000"/>
+            <a:ext cx="10972800" cy="304800"/>
+          </a:xfrm>
+          <a:prstGeom prst="rect">
+            <a:avLst/>
+          </a:prstGeom>
+          <a:noFill/>
+        </p:spPr>
+        <p:txBody>
+          <a:bodyPr wrap="square">
+            <a:spAutoFit/>
+          </a:bodyPr>
+          <a:lstStyle/>
+          <a:p>
+            <a:r>
+              <a:rPr sz="1100">
+                <a:solidFill>
+                  <a:srgbClr val="5B6B7F"/>
+                </a:solidFill>
+              </a:rPr>
+              <a:t>SkyRoute  ·  DBMS mini project  ·  skyroute_db (MySQL 8.0)</a:t>
+            </a:r>
+          </a:p>
+        </p:txBody>
+      </p:sp>
+      <p:sp>
+        <p:nvSpPr>
+          <p:cNvPr id="6" name="TextBox 5"/>
+          <p:cNvSpPr txBox="1"/>
+          <p:nvPr/>
+        </p:nvSpPr>
+        <p:spPr>
+          <a:xfrm>
+            <a:off x="609600" y="1905000"/>
+            <a:ext cx="10972800" cy="4191000"/>
+          </a:xfrm>
+          <a:prstGeom prst="rect">
+            <a:avLst/>
+          </a:prstGeom>
+          <a:noFill/>
+        </p:spPr>
+        <p:txBody>
+          <a:bodyPr wrap="square">
+            <a:spAutoFit/>
+          </a:bodyPr>
+          <a:lstStyle/>
+          <a:p>
+            <a:pPr>
+              <a:spcAft>
+                <a:spcPts val="1000"/>
+              </a:spcAft>
+            </a:pPr>
+            <a:r>
+              <a:rPr sz="1900" b="1">
+                <a:solidFill>
+                  <a:srgbClr val="0F2540"/>
+                </a:solidFill>
+              </a:rPr>
+              <a:t>▸ Demo A — commit  </a:t>
+            </a:r>
+            <a:r>
+              <a:rPr sz="1900">
+                <a:solidFill>
+                  <a:srgbClr val="222222"/>
+                </a:solidFill>
+              </a:rPr>
+              <a:t>booking + payment appear together.</a:t>
+            </a:r>
+          </a:p>
+          <a:p>
+            <a:pPr>
+              <a:spcAft>
+                <a:spcPts val="1000"/>
+              </a:spcAft>
+            </a:pPr>
+            <a:r>
+              <a:rPr sz="1900" b="1">
+                <a:solidFill>
+                  <a:srgbClr val="0F2540"/>
+                </a:solidFill>
+              </a:rPr>
+              <a:t>▸ Demo B — rollback  </a:t>
+            </a:r>
+            <a:r>
+              <a:rPr sz="1900">
+                <a:solidFill>
+                  <a:srgbClr val="222222"/>
+                </a:solidFill>
+              </a:rPr>
+              <a:t>failed payment → seat provably still free.</a:t>
+            </a:r>
+          </a:p>
+          <a:p>
+            <a:pPr>
+              <a:spcAft>
+                <a:spcPts val="1000"/>
+              </a:spcAft>
+            </a:pPr>
+            <a:r>
+              <a:rPr sz="1900" b="1">
+                <a:solidFill>
+                  <a:srgbClr val="0F2540"/>
+                </a:solidFill>
+              </a:rPr>
+              <a:t>▸ Demo C — isolation  </a:t>
+            </a:r>
+            <a:r>
+              <a:rPr sz="1900">
+                <a:solidFill>
+                  <a:srgbClr val="222222"/>
+                </a:solidFill>
+              </a:rPr>
+              <a:t>two sessions: old value visible until COMMIT.</a:t>
             </a:r>
           </a:p>
         </p:txBody>
@@ -3954,14 +5752,57 @@
       <p:grpSpPr/>
       <p:sp>
         <p:nvSpPr>
-          <p:cNvPr id="2" name="TextBox 1"/>
+          <p:cNvPr id="2" name="Rectangle 1"/>
+          <p:cNvSpPr/>
+          <p:nvPr/>
+        </p:nvSpPr>
+        <p:spPr>
+          <a:xfrm>
+            <a:off x="0" y="0"/>
+            <a:ext cx="12192000" cy="1651000"/>
+          </a:xfrm>
+          <a:prstGeom prst="rect">
+            <a:avLst/>
+          </a:prstGeom>
+          <a:solidFill>
+            <a:srgbClr val="0F2540"/>
+          </a:solidFill>
+          <a:ln>
+            <a:noFill/>
+          </a:ln>
+        </p:spPr>
+        <p:style>
+          <a:lnRef idx="1">
+            <a:schemeClr val="accent1"/>
+          </a:lnRef>
+          <a:fillRef idx="3">
+            <a:schemeClr val="accent1"/>
+          </a:fillRef>
+          <a:effectRef idx="2">
+            <a:schemeClr val="accent1"/>
+          </a:effectRef>
+          <a:fontRef idx="minor">
+            <a:schemeClr val="lt1"/>
+          </a:fontRef>
+        </p:style>
+        <p:txBody>
+          <a:bodyPr rtlCol="0" anchor="ctr"/>
+          <a:lstStyle/>
+          <a:p>
+            <a:pPr algn="ctr"/>
+          </a:p>
+        </p:txBody>
+      </p:sp>
+      <p:sp>
+        <p:nvSpPr>
+          <p:cNvPr id="3" name="TextBox 2"/>
           <p:cNvSpPr txBox="1"/>
           <p:nvPr/>
         </p:nvSpPr>
         <p:spPr>
           <a:xfrm>
-            <a:off x="508000" y="254000"/>
-            <a:ext cx="11176000" cy="1016000"/>
+            <a:off x="609600" y="279400"/>
+            <a:ext cx="10972800" cy="381000"/>
           </a:xfrm>
           <a:prstGeom prst="rect">
             <a:avLst/>
@@ -3969,28 +5810,32 @@
           <a:noFill/>
         </p:spPr>
         <p:txBody>
-          <a:bodyPr wrap="none">
+          <a:bodyPr wrap="square">
             <a:spAutoFit/>
           </a:bodyPr>
           <a:lstStyle/>
           <a:p>
             <a:r>
-              <a:rPr sz="3200" b="1"/>
-              <a:t>Indexing + cost</a:t>
-            </a:r>
-          </a:p>
-        </p:txBody>
-      </p:sp>
-      <p:sp>
-        <p:nvSpPr>
-          <p:cNvPr id="3" name="TextBox 2"/>
+              <a:rPr sz="1300" b="1">
+                <a:solidFill>
+                  <a:srgbClr val="F5A623"/>
+                </a:solidFill>
+              </a:rPr>
+              <a:t>SKYROUTE</a:t>
+            </a:r>
+          </a:p>
+        </p:txBody>
+      </p:sp>
+      <p:sp>
+        <p:nvSpPr>
+          <p:cNvPr id="4" name="TextBox 3"/>
           <p:cNvSpPr txBox="1"/>
           <p:nvPr/>
         </p:nvSpPr>
         <p:spPr>
           <a:xfrm>
-            <a:off x="508000" y="1524000"/>
-            <a:ext cx="11176000" cy="4826000"/>
+            <a:off x="609600" y="609600"/>
+            <a:ext cx="10972800" cy="889000"/>
           </a:xfrm>
           <a:prstGeom prst="rect">
             <a:avLst/>
@@ -4003,24 +5848,138 @@
           </a:bodyPr>
           <a:lstStyle/>
           <a:p>
-            <a:pPr/>
-            <a:r>
-              <a:rPr sz="2000"/>
-              <a:t>•  No re-indexing of auto-indexed FKs — only workload filters</a:t>
-            </a:r>
-          </a:p>
-          <a:p>
-            <a:pPr/>
-            <a:r>
-              <a:rPr sz="2000"/>
-              <a:t>•  4 indexes: status, departure date, surname, bag weight</a:t>
-            </a:r>
-          </a:p>
-          <a:p>
-            <a:pPr/>
-            <a:r>
-              <a:rPr sz="2000"/>
-              <a:t>•  Before/after EXPLAIN pairs captured in the test log</a:t>
+            <a:r>
+              <a:rPr sz="3000" b="1">
+                <a:solidFill>
+                  <a:srgbClr val="FFFFFF"/>
+                </a:solidFill>
+              </a:rPr>
+              <a:t>Indexing: measure, don't guess</a:t>
+            </a:r>
+          </a:p>
+        </p:txBody>
+      </p:sp>
+      <p:sp>
+        <p:nvSpPr>
+          <p:cNvPr id="5" name="TextBox 4"/>
+          <p:cNvSpPr txBox="1"/>
+          <p:nvPr/>
+        </p:nvSpPr>
+        <p:spPr>
+          <a:xfrm>
+            <a:off x="609600" y="6350000"/>
+            <a:ext cx="10972800" cy="304800"/>
+          </a:xfrm>
+          <a:prstGeom prst="rect">
+            <a:avLst/>
+          </a:prstGeom>
+          <a:noFill/>
+        </p:spPr>
+        <p:txBody>
+          <a:bodyPr wrap="square">
+            <a:spAutoFit/>
+          </a:bodyPr>
+          <a:lstStyle/>
+          <a:p>
+            <a:r>
+              <a:rPr sz="1100">
+                <a:solidFill>
+                  <a:srgbClr val="5B6B7F"/>
+                </a:solidFill>
+              </a:rPr>
+              <a:t>SkyRoute  ·  DBMS mini project  ·  skyroute_db (MySQL 8.0)</a:t>
+            </a:r>
+          </a:p>
+        </p:txBody>
+      </p:sp>
+      <p:sp>
+        <p:nvSpPr>
+          <p:cNvPr id="6" name="TextBox 5"/>
+          <p:cNvSpPr txBox="1"/>
+          <p:nvPr/>
+        </p:nvSpPr>
+        <p:spPr>
+          <a:xfrm>
+            <a:off x="609600" y="1905000"/>
+            <a:ext cx="10972800" cy="4191000"/>
+          </a:xfrm>
+          <a:prstGeom prst="rect">
+            <a:avLst/>
+          </a:prstGeom>
+          <a:noFill/>
+        </p:spPr>
+        <p:txBody>
+          <a:bodyPr wrap="square">
+            <a:spAutoFit/>
+          </a:bodyPr>
+          <a:lstStyle/>
+          <a:p>
+            <a:pPr>
+              <a:spcAft>
+                <a:spcPts val="1000"/>
+              </a:spcAft>
+            </a:pPr>
+            <a:r>
+              <a:rPr sz="1900" b="1">
+                <a:solidFill>
+                  <a:srgbClr val="0F2540"/>
+                </a:solidFill>
+              </a:rPr>
+              <a:t>▸ No cargo cult  </a:t>
+            </a:r>
+            <a:r>
+              <a:rPr sz="1900">
+                <a:solidFill>
+                  <a:srgbClr val="222222"/>
+                </a:solidFill>
+              </a:rPr>
+              <a:t>InnoDB already indexes FK columns — untouched.</a:t>
+            </a:r>
+          </a:p>
+          <a:p>
+            <a:pPr>
+              <a:spcAft>
+                <a:spcPts val="1000"/>
+              </a:spcAft>
+            </a:pPr>
+            <a:r>
+              <a:rPr sz="1900" b="1">
+                <a:solidFill>
+                  <a:srgbClr val="0F2540"/>
+                </a:solidFill>
+              </a:rPr>
+              <a:t>▸ 4 workload indexes  </a:t>
+            </a:r>
+            <a:r>
+              <a:rPr sz="1900">
+                <a:solidFill>
+                  <a:srgbClr val="222222"/>
+                </a:solidFill>
+              </a:rPr>
+              <a:t>status · departure date · surname · bag weight.</a:t>
+            </a:r>
+          </a:p>
+          <a:p>
+            <a:pPr>
+              <a:spcAft>
+                <a:spcPts val="1000"/>
+              </a:spcAft>
+            </a:pPr>
+            <a:r>
+              <a:rPr sz="1900" b="1">
+                <a:solidFill>
+                  <a:srgbClr val="0F2540"/>
+                </a:solidFill>
+              </a:rPr>
+              <a:t>▸ Proof  </a:t>
+            </a:r>
+            <a:r>
+              <a:rPr sz="1900">
+                <a:solidFill>
+                  <a:srgbClr val="222222"/>
+                </a:solidFill>
+              </a:rPr>
+              <a:t>before/after EXPLAIN pairs: fewer rows examined.</a:t>
             </a:r>
           </a:p>
         </p:txBody>
@@ -4045,14 +6004,57 @@
       <p:grpSpPr/>
       <p:sp>
         <p:nvSpPr>
-          <p:cNvPr id="2" name="TextBox 1"/>
+          <p:cNvPr id="2" name="Rectangle 1"/>
+          <p:cNvSpPr/>
+          <p:nvPr/>
+        </p:nvSpPr>
+        <p:spPr>
+          <a:xfrm>
+            <a:off x="0" y="0"/>
+            <a:ext cx="12192000" cy="1651000"/>
+          </a:xfrm>
+          <a:prstGeom prst="rect">
+            <a:avLst/>
+          </a:prstGeom>
+          <a:solidFill>
+            <a:srgbClr val="0F2540"/>
+          </a:solidFill>
+          <a:ln>
+            <a:noFill/>
+          </a:ln>
+        </p:spPr>
+        <p:style>
+          <a:lnRef idx="1">
+            <a:schemeClr val="accent1"/>
+          </a:lnRef>
+          <a:fillRef idx="3">
+            <a:schemeClr val="accent1"/>
+          </a:fillRef>
+          <a:effectRef idx="2">
+            <a:schemeClr val="accent1"/>
+          </a:effectRef>
+          <a:fontRef idx="minor">
+            <a:schemeClr val="lt1"/>
+          </a:fontRef>
+        </p:style>
+        <p:txBody>
+          <a:bodyPr rtlCol="0" anchor="ctr"/>
+          <a:lstStyle/>
+          <a:p>
+            <a:pPr algn="ctr"/>
+          </a:p>
+        </p:txBody>
+      </p:sp>
+      <p:sp>
+        <p:nvSpPr>
+          <p:cNvPr id="3" name="TextBox 2"/>
           <p:cNvSpPr txBox="1"/>
           <p:nvPr/>
         </p:nvSpPr>
         <p:spPr>
           <a:xfrm>
-            <a:off x="508000" y="254000"/>
-            <a:ext cx="11176000" cy="1016000"/>
+            <a:off x="609600" y="279400"/>
+            <a:ext cx="10972800" cy="381000"/>
           </a:xfrm>
           <a:prstGeom prst="rect">
             <a:avLst/>
@@ -4060,28 +6062,32 @@
           <a:noFill/>
         </p:spPr>
         <p:txBody>
-          <a:bodyPr wrap="none">
+          <a:bodyPr wrap="square">
             <a:spAutoFit/>
           </a:bodyPr>
           <a:lstStyle/>
           <a:p>
             <a:r>
-              <a:rPr sz="3200" b="1"/>
-              <a:t>Access control</a:t>
-            </a:r>
-          </a:p>
-        </p:txBody>
-      </p:sp>
-      <p:sp>
-        <p:nvSpPr>
-          <p:cNvPr id="3" name="TextBox 2"/>
+              <a:rPr sz="1300" b="1">
+                <a:solidFill>
+                  <a:srgbClr val="F5A623"/>
+                </a:solidFill>
+              </a:rPr>
+              <a:t>SKYROUTE</a:t>
+            </a:r>
+          </a:p>
+        </p:txBody>
+      </p:sp>
+      <p:sp>
+        <p:nvSpPr>
+          <p:cNvPr id="4" name="TextBox 3"/>
           <p:cNvSpPr txBox="1"/>
           <p:nvPr/>
         </p:nvSpPr>
         <p:spPr>
           <a:xfrm>
-            <a:off x="508000" y="1524000"/>
-            <a:ext cx="11176000" cy="4826000"/>
+            <a:off x="609600" y="609600"/>
+            <a:ext cx="10972800" cy="889000"/>
           </a:xfrm>
           <a:prstGeom prst="rect">
             <a:avLst/>
@@ -4094,24 +6100,138 @@
           </a:bodyPr>
           <a:lstStyle/>
           <a:p>
-            <a:pPr/>
-            <a:r>
-              <a:rPr sz="2000"/>
-              <a:t>•  sky_admin: all privileges; sky_staff: read-write; sky_viewer: read-only</a:t>
-            </a:r>
-          </a:p>
-          <a:p>
-            <a:pPr/>
-            <a:r>
-              <a:rPr sz="2000"/>
-              <a:t>•  Grants verified with SHOW GRANTS on the exact database name</a:t>
-            </a:r>
-          </a:p>
-          <a:p>
-            <a:pPr/>
-            <a:r>
-              <a:rPr sz="2000"/>
-              <a:t>•  Viewer INSERT denied — least privilege proven, not claimed</a:t>
+            <a:r>
+              <a:rPr sz="3000" b="1">
+                <a:solidFill>
+                  <a:srgbClr val="FFFFFF"/>
+                </a:solidFill>
+              </a:rPr>
+              <a:t>Access control + testing</a:t>
+            </a:r>
+          </a:p>
+        </p:txBody>
+      </p:sp>
+      <p:sp>
+        <p:nvSpPr>
+          <p:cNvPr id="5" name="TextBox 4"/>
+          <p:cNvSpPr txBox="1"/>
+          <p:nvPr/>
+        </p:nvSpPr>
+        <p:spPr>
+          <a:xfrm>
+            <a:off x="609600" y="6350000"/>
+            <a:ext cx="10972800" cy="304800"/>
+          </a:xfrm>
+          <a:prstGeom prst="rect">
+            <a:avLst/>
+          </a:prstGeom>
+          <a:noFill/>
+        </p:spPr>
+        <p:txBody>
+          <a:bodyPr wrap="square">
+            <a:spAutoFit/>
+          </a:bodyPr>
+          <a:lstStyle/>
+          <a:p>
+            <a:r>
+              <a:rPr sz="1100">
+                <a:solidFill>
+                  <a:srgbClr val="5B6B7F"/>
+                </a:solidFill>
+              </a:rPr>
+              <a:t>SkyRoute  ·  DBMS mini project  ·  skyroute_db (MySQL 8.0)</a:t>
+            </a:r>
+          </a:p>
+        </p:txBody>
+      </p:sp>
+      <p:sp>
+        <p:nvSpPr>
+          <p:cNvPr id="6" name="TextBox 5"/>
+          <p:cNvSpPr txBox="1"/>
+          <p:nvPr/>
+        </p:nvSpPr>
+        <p:spPr>
+          <a:xfrm>
+            <a:off x="609600" y="1905000"/>
+            <a:ext cx="10972800" cy="4191000"/>
+          </a:xfrm>
+          <a:prstGeom prst="rect">
+            <a:avLst/>
+          </a:prstGeom>
+          <a:noFill/>
+        </p:spPr>
+        <p:txBody>
+          <a:bodyPr wrap="square">
+            <a:spAutoFit/>
+          </a:bodyPr>
+          <a:lstStyle/>
+          <a:p>
+            <a:pPr>
+              <a:spcAft>
+                <a:spcPts val="1000"/>
+              </a:spcAft>
+            </a:pPr>
+            <a:r>
+              <a:rPr sz="1900" b="1">
+                <a:solidFill>
+                  <a:srgbClr val="0F2540"/>
+                </a:solidFill>
+              </a:rPr>
+              <a:t>▸ 3 roles  </a:t>
+            </a:r>
+            <a:r>
+              <a:rPr sz="1900">
+                <a:solidFill>
+                  <a:srgbClr val="222222"/>
+                </a:solidFill>
+              </a:rPr>
+              <a:t>admin = all · staff = read-write · viewer = read-only, SHOW GRANTS proof.</a:t>
+            </a:r>
+          </a:p>
+          <a:p>
+            <a:pPr>
+              <a:spcAft>
+                <a:spcPts val="1000"/>
+              </a:spcAft>
+            </a:pPr>
+            <a:r>
+              <a:rPr sz="1900" b="1">
+                <a:solidFill>
+                  <a:srgbClr val="0F2540"/>
+                </a:solidFill>
+              </a:rPr>
+              <a:t>▸ 30 checks  </a:t>
+            </a:r>
+            <a:r>
+              <a:rPr sz="1900">
+                <a:solidFill>
+                  <a:srgbClr val="222222"/>
+                </a:solidFill>
+              </a:rPr>
+              <a:t>joins · analytics · rejections (ERROR 1062 live) · atomicity · grants · scale.</a:t>
+            </a:r>
+          </a:p>
+          <a:p>
+            <a:pPr>
+              <a:spcAft>
+                <a:spcPts val="1000"/>
+              </a:spcAft>
+            </a:pPr>
+            <a:r>
+              <a:rPr sz="1900" b="1">
+                <a:solidFill>
+                  <a:srgbClr val="0F2540"/>
+                </a:solidFill>
+              </a:rPr>
+              <a:t>▸ Every check  </a:t>
+            </a:r>
+            <a:r>
+              <a:rPr sz="1900">
+                <a:solidFill>
+                  <a:srgbClr val="222222"/>
+                </a:solidFill>
+              </a:rPr>
+              <a:t>states its expected result before the run.</a:t>
             </a:r>
           </a:p>
         </p:txBody>

</xml_diff>

<commit_message>
Docs official 15-page, 336 departures, themed slides with notes, themed PDF
</commit_message>
<xml_diff>
--- a/dbms/docs/SkyRoute_Slides.pptx
+++ b/dbms/docs/SkyRoute_Slides.pptx
@@ -115,6 +115,1126 @@
     </a:lvl9pPr>
   </p:defaultTextStyle>
 </p:presentation>
+</file>
+
+<file path=ppt/notesMasters/notesMaster1.xml><?xml version="1.0" encoding="utf-8"?>
+<p:notesMaster xmlns:a="http://schemas.openxmlformats.org/drawingml/2006/main" xmlns:p="http://schemas.openxmlformats.org/presentationml/2006/main" xmlns:r="http://schemas.openxmlformats.org/officeDocument/2006/relationships">
+  <p:cSld>
+    <p:bg>
+      <p:bgRef idx="1001">
+        <a:schemeClr val="bg1"/>
+      </p:bgRef>
+    </p:bg>
+    <p:spTree>
+      <p:nvGrpSpPr>
+        <p:cNvPr id="1" name=""/>
+        <p:cNvGrpSpPr/>
+        <p:nvPr/>
+      </p:nvGrpSpPr>
+      <p:grpSpPr>
+        <a:xfrm>
+          <a:off x="0" y="0"/>
+          <a:ext cx="0" cy="0"/>
+          <a:chOff x="0" y="0"/>
+          <a:chExt cx="0" cy="0"/>
+        </a:xfrm>
+      </p:grpSpPr>
+      <p:sp>
+        <p:nvSpPr>
+          <p:cNvPr id="2" name="Header Placeholder 1"/>
+          <p:cNvSpPr>
+            <a:spLocks noGrp="1"/>
+          </p:cNvSpPr>
+          <p:nvPr>
+            <p:ph type="hdr" sz="quarter"/>
+          </p:nvPr>
+        </p:nvSpPr>
+        <p:spPr>
+          <a:xfrm>
+            <a:off x="0" y="0"/>
+            <a:ext cx="2971800" cy="457200"/>
+          </a:xfrm>
+          <a:prstGeom prst="rect">
+            <a:avLst/>
+          </a:prstGeom>
+        </p:spPr>
+        <p:txBody>
+          <a:bodyPr vert="horz" lIns="91440" tIns="45720" rIns="91440" bIns="45720" rtlCol="0"/>
+          <a:lstStyle>
+            <a:lvl1pPr algn="l">
+              <a:defRPr sz="1200"/>
+            </a:lvl1pPr>
+          </a:lstStyle>
+          <a:p>
+            <a:endParaRPr lang="en-US"/>
+          </a:p>
+        </p:txBody>
+      </p:sp>
+      <p:sp>
+        <p:nvSpPr>
+          <p:cNvPr id="3" name="Date Placeholder 2"/>
+          <p:cNvSpPr>
+            <a:spLocks noGrp="1"/>
+          </p:cNvSpPr>
+          <p:nvPr>
+            <p:ph type="dt" idx="1"/>
+          </p:nvPr>
+        </p:nvSpPr>
+        <p:spPr>
+          <a:xfrm>
+            <a:off x="3884613" y="0"/>
+            <a:ext cx="2971800" cy="457200"/>
+          </a:xfrm>
+          <a:prstGeom prst="rect">
+            <a:avLst/>
+          </a:prstGeom>
+        </p:spPr>
+        <p:txBody>
+          <a:bodyPr vert="horz" lIns="91440" tIns="45720" rIns="91440" bIns="45720" rtlCol="0"/>
+          <a:lstStyle>
+            <a:lvl1pPr algn="r">
+              <a:defRPr sz="1200"/>
+            </a:lvl1pPr>
+          </a:lstStyle>
+          <a:p>
+            <a:fld id="{0F89C1C7-3DCD-1040-A9CF-14679D8B5DDD}" type="datetimeFigureOut">
+              <a:rPr lang="en-US" smtClean="0"/>
+              <a:t>10/17/16</a:t>
+            </a:fld>
+            <a:endParaRPr lang="en-US"/>
+          </a:p>
+        </p:txBody>
+      </p:sp>
+      <p:sp>
+        <p:nvSpPr>
+          <p:cNvPr id="4" name="Slide Image Placeholder 3"/>
+          <p:cNvSpPr>
+            <a:spLocks noGrp="1" noRot="1" noChangeAspect="1"/>
+          </p:cNvSpPr>
+          <p:nvPr>
+            <p:ph type="sldImg" idx="2"/>
+          </p:nvPr>
+        </p:nvSpPr>
+        <p:spPr>
+          <a:xfrm>
+            <a:off x="1143000" y="685800"/>
+            <a:ext cx="4572000" cy="3429000"/>
+          </a:xfrm>
+          <a:prstGeom prst="rect">
+            <a:avLst/>
+          </a:prstGeom>
+          <a:noFill/>
+          <a:ln w="12700">
+            <a:solidFill>
+              <a:prstClr val="black"/>
+            </a:solidFill>
+          </a:ln>
+        </p:spPr>
+        <p:txBody>
+          <a:bodyPr vert="horz" lIns="91440" tIns="45720" rIns="91440" bIns="45720" rtlCol="0" anchor="ctr"/>
+          <a:lstStyle/>
+          <a:p>
+            <a:endParaRPr lang="en-US"/>
+          </a:p>
+        </p:txBody>
+      </p:sp>
+      <p:sp>
+        <p:nvSpPr>
+          <p:cNvPr id="5" name="Notes Placeholder 4"/>
+          <p:cNvSpPr>
+            <a:spLocks noGrp="1"/>
+          </p:cNvSpPr>
+          <p:nvPr>
+            <p:ph type="body" sz="quarter" idx="3"/>
+          </p:nvPr>
+        </p:nvSpPr>
+        <p:spPr>
+          <a:xfrm>
+            <a:off x="685800" y="4343400"/>
+            <a:ext cx="5486400" cy="4114800"/>
+          </a:xfrm>
+          <a:prstGeom prst="rect">
+            <a:avLst/>
+          </a:prstGeom>
+        </p:spPr>
+        <p:txBody>
+          <a:bodyPr vert="horz" lIns="91440" tIns="45720" rIns="91440" bIns="45720" rtlCol="0"/>
+          <a:lstStyle/>
+          <a:p>
+            <a:pPr lvl="0"/>
+            <a:r>
+              <a:rPr lang="en-US" smtClean="0"/>
+              <a:t>Click to edit Master text styles</a:t>
+            </a:r>
+          </a:p>
+          <a:p>
+            <a:pPr lvl="1"/>
+            <a:r>
+              <a:rPr lang="en-US" smtClean="0"/>
+              <a:t>Second level</a:t>
+            </a:r>
+          </a:p>
+          <a:p>
+            <a:pPr lvl="2"/>
+            <a:r>
+              <a:rPr lang="en-US" smtClean="0"/>
+              <a:t>Third level</a:t>
+            </a:r>
+          </a:p>
+          <a:p>
+            <a:pPr lvl="3"/>
+            <a:r>
+              <a:rPr lang="en-US" smtClean="0"/>
+              <a:t>Fourth level</a:t>
+            </a:r>
+          </a:p>
+          <a:p>
+            <a:pPr lvl="4"/>
+            <a:r>
+              <a:rPr lang="en-US" smtClean="0"/>
+              <a:t>Fifth level</a:t>
+            </a:r>
+            <a:endParaRPr lang="en-US"/>
+          </a:p>
+        </p:txBody>
+      </p:sp>
+      <p:sp>
+        <p:nvSpPr>
+          <p:cNvPr id="6" name="Footer Placeholder 5"/>
+          <p:cNvSpPr>
+            <a:spLocks noGrp="1"/>
+          </p:cNvSpPr>
+          <p:nvPr>
+            <p:ph type="ftr" sz="quarter" idx="4"/>
+          </p:nvPr>
+        </p:nvSpPr>
+        <p:spPr>
+          <a:xfrm>
+            <a:off x="0" y="8685213"/>
+            <a:ext cx="2971800" cy="457200"/>
+          </a:xfrm>
+          <a:prstGeom prst="rect">
+            <a:avLst/>
+          </a:prstGeom>
+        </p:spPr>
+        <p:txBody>
+          <a:bodyPr vert="horz" lIns="91440" tIns="45720" rIns="91440" bIns="45720" rtlCol="0" anchor="b"/>
+          <a:lstStyle>
+            <a:lvl1pPr algn="l">
+              <a:defRPr sz="1200"/>
+            </a:lvl1pPr>
+          </a:lstStyle>
+          <a:p>
+            <a:endParaRPr lang="en-US"/>
+          </a:p>
+        </p:txBody>
+      </p:sp>
+      <p:sp>
+        <p:nvSpPr>
+          <p:cNvPr id="7" name="Slide Number Placeholder 6"/>
+          <p:cNvSpPr>
+            <a:spLocks noGrp="1"/>
+          </p:cNvSpPr>
+          <p:nvPr>
+            <p:ph type="sldNum" sz="quarter" idx="5"/>
+          </p:nvPr>
+        </p:nvSpPr>
+        <p:spPr>
+          <a:xfrm>
+            <a:off x="3884613" y="8685213"/>
+            <a:ext cx="2971800" cy="457200"/>
+          </a:xfrm>
+          <a:prstGeom prst="rect">
+            <a:avLst/>
+          </a:prstGeom>
+        </p:spPr>
+        <p:txBody>
+          <a:bodyPr vert="horz" lIns="91440" tIns="45720" rIns="91440" bIns="45720" rtlCol="0" anchor="b"/>
+          <a:lstStyle>
+            <a:lvl1pPr algn="r">
+              <a:defRPr sz="1200"/>
+            </a:lvl1pPr>
+          </a:lstStyle>
+          <a:p>
+            <a:fld id="{BB5E49A5-4136-284D-997B-48E1D791AD67}" type="slidenum">
+              <a:rPr lang="en-US" smtClean="0"/>
+              <a:t>‹#›</a:t>
+            </a:fld>
+            <a:endParaRPr lang="en-US"/>
+          </a:p>
+        </p:txBody>
+      </p:sp>
+    </p:spTree>
+    <p:extLst>
+      <p:ext uri="{BB962C8B-B14F-4D97-AF65-F5344CB8AC3E}">
+        <p14:creationId xmlns:p14="http://schemas.microsoft.com/office/powerpoint/2010/main" val="2623252185"/>
+      </p:ext>
+    </p:extLst>
+  </p:cSld>
+  <p:clrMap bg1="lt1" tx1="dk1" bg2="lt2" tx2="dk2" accent1="accent1" accent2="accent2" accent3="accent3" accent4="accent4" accent5="accent5" accent6="accent6" hlink="hlink" folHlink="folHlink"/>
+  <p:notesStyle>
+    <a:lvl1pPr marL="0" algn="l" defTabSz="457200" rtl="0" eaLnBrk="1" latinLnBrk="0" hangingPunct="1">
+      <a:defRPr sz="1200" kern="1200">
+        <a:solidFill>
+          <a:schemeClr val="tx1"/>
+        </a:solidFill>
+        <a:latin typeface="+mn-lt"/>
+        <a:ea typeface="+mn-ea"/>
+        <a:cs typeface="+mn-cs"/>
+      </a:defRPr>
+    </a:lvl1pPr>
+    <a:lvl2pPr marL="457200" algn="l" defTabSz="457200" rtl="0" eaLnBrk="1" latinLnBrk="0" hangingPunct="1">
+      <a:defRPr sz="1200" kern="1200">
+        <a:solidFill>
+          <a:schemeClr val="tx1"/>
+        </a:solidFill>
+        <a:latin typeface="+mn-lt"/>
+        <a:ea typeface="+mn-ea"/>
+        <a:cs typeface="+mn-cs"/>
+      </a:defRPr>
+    </a:lvl2pPr>
+    <a:lvl3pPr marL="914400" algn="l" defTabSz="457200" rtl="0" eaLnBrk="1" latinLnBrk="0" hangingPunct="1">
+      <a:defRPr sz="1200" kern="1200">
+        <a:solidFill>
+          <a:schemeClr val="tx1"/>
+        </a:solidFill>
+        <a:latin typeface="+mn-lt"/>
+        <a:ea typeface="+mn-ea"/>
+        <a:cs typeface="+mn-cs"/>
+      </a:defRPr>
+    </a:lvl3pPr>
+    <a:lvl4pPr marL="1371600" algn="l" defTabSz="457200" rtl="0" eaLnBrk="1" latinLnBrk="0" hangingPunct="1">
+      <a:defRPr sz="1200" kern="1200">
+        <a:solidFill>
+          <a:schemeClr val="tx1"/>
+        </a:solidFill>
+        <a:latin typeface="+mn-lt"/>
+        <a:ea typeface="+mn-ea"/>
+        <a:cs typeface="+mn-cs"/>
+      </a:defRPr>
+    </a:lvl4pPr>
+    <a:lvl5pPr marL="1828800" algn="l" defTabSz="457200" rtl="0" eaLnBrk="1" latinLnBrk="0" hangingPunct="1">
+      <a:defRPr sz="1200" kern="1200">
+        <a:solidFill>
+          <a:schemeClr val="tx1"/>
+        </a:solidFill>
+        <a:latin typeface="+mn-lt"/>
+        <a:ea typeface="+mn-ea"/>
+        <a:cs typeface="+mn-cs"/>
+      </a:defRPr>
+    </a:lvl5pPr>
+    <a:lvl6pPr marL="2286000" algn="l" defTabSz="457200" rtl="0" eaLnBrk="1" latinLnBrk="0" hangingPunct="1">
+      <a:defRPr sz="1200" kern="1200">
+        <a:solidFill>
+          <a:schemeClr val="tx1"/>
+        </a:solidFill>
+        <a:latin typeface="+mn-lt"/>
+        <a:ea typeface="+mn-ea"/>
+        <a:cs typeface="+mn-cs"/>
+      </a:defRPr>
+    </a:lvl6pPr>
+    <a:lvl7pPr marL="2743200" algn="l" defTabSz="457200" rtl="0" eaLnBrk="1" latinLnBrk="0" hangingPunct="1">
+      <a:defRPr sz="1200" kern="1200">
+        <a:solidFill>
+          <a:schemeClr val="tx1"/>
+        </a:solidFill>
+        <a:latin typeface="+mn-lt"/>
+        <a:ea typeface="+mn-ea"/>
+        <a:cs typeface="+mn-cs"/>
+      </a:defRPr>
+    </a:lvl7pPr>
+    <a:lvl8pPr marL="3200400" algn="l" defTabSz="457200" rtl="0" eaLnBrk="1" latinLnBrk="0" hangingPunct="1">
+      <a:defRPr sz="1200" kern="1200">
+        <a:solidFill>
+          <a:schemeClr val="tx1"/>
+        </a:solidFill>
+        <a:latin typeface="+mn-lt"/>
+        <a:ea typeface="+mn-ea"/>
+        <a:cs typeface="+mn-cs"/>
+      </a:defRPr>
+    </a:lvl8pPr>
+    <a:lvl9pPr marL="3657600" algn="l" defTabSz="457200" rtl="0" eaLnBrk="1" latinLnBrk="0" hangingPunct="1">
+      <a:defRPr sz="1200" kern="1200">
+        <a:solidFill>
+          <a:schemeClr val="tx1"/>
+        </a:solidFill>
+        <a:latin typeface="+mn-lt"/>
+        <a:ea typeface="+mn-ea"/>
+        <a:cs typeface="+mn-cs"/>
+      </a:defRPr>
+    </a:lvl9pPr>
+  </p:notesStyle>
+</p:notesMaster>
+</file>
+
+<file path=ppt/notesSlides/notesSlide1.xml><?xml version="1.0" encoding="utf-8"?>
+<p:notes xmlns:a="http://schemas.openxmlformats.org/drawingml/2006/main" xmlns:p="http://schemas.openxmlformats.org/presentationml/2006/main" xmlns:r="http://schemas.openxmlformats.org/officeDocument/2006/relationships">
+  <p:cSld>
+    <p:spTree>
+      <p:nvGrpSpPr>
+        <p:cNvPr id="1" name=""/>
+        <p:cNvGrpSpPr/>
+        <p:nvPr/>
+      </p:nvGrpSpPr>
+      <p:grpSpPr>
+        <a:xfrm>
+          <a:off x="0" y="0"/>
+          <a:ext cx="0" cy="0"/>
+          <a:chOff x="0" y="0"/>
+          <a:chExt cx="0" cy="0"/>
+        </a:xfrm>
+      </p:grpSpPr>
+      <p:sp>
+        <p:nvSpPr>
+          <p:cNvPr id="2" name="Slide Image Placeholder 1"/>
+          <p:cNvSpPr>
+            <a:spLocks noGrp="1"/>
+          </p:cNvSpPr>
+          <p:nvPr>
+            <p:ph type="sldImg" idx="2"/>
+          </p:nvPr>
+        </p:nvSpPr>
+        <p:spPr/>
+      </p:sp>
+      <p:sp>
+        <p:nvSpPr>
+          <p:cNvPr id="3" name="Notes Placeholder 2"/>
+          <p:cNvSpPr>
+            <a:spLocks noGrp="1"/>
+          </p:cNvSpPr>
+          <p:nvPr>
+            <p:ph type="body" idx="3" sz="quarter"/>
+          </p:nvPr>
+        </p:nvSpPr>
+        <p:spPr/>
+        <p:txBody>
+          <a:bodyPr/>
+          <a:lstStyle/>
+          <a:p>
+            <a:r>
+              <a:t>Cover. Animation: headline words fly in one by one; plane motif draws across. Say: one database for every station.</a:t>
+            </a:r>
+          </a:p>
+        </p:txBody>
+      </p:sp>
+      <p:sp>
+        <p:nvSpPr>
+          <p:cNvPr id="4" name="Slide Number Placeholder 3"/>
+          <p:cNvSpPr>
+            <a:spLocks noGrp="1"/>
+          </p:cNvSpPr>
+          <p:nvPr>
+            <p:ph type="sldNum" idx="5" sz="quarter"/>
+          </p:nvPr>
+        </p:nvSpPr>
+        <p:spPr/>
+      </p:sp>
+    </p:spTree>
+  </p:cSld>
+  <p:clrMapOvr>
+    <a:masterClrMapping/>
+  </p:clrMapOvr>
+</p:notes>
+</file>
+
+<file path=ppt/notesSlides/notesSlide10.xml><?xml version="1.0" encoding="utf-8"?>
+<p:notes xmlns:a="http://schemas.openxmlformats.org/drawingml/2006/main" xmlns:p="http://schemas.openxmlformats.org/presentationml/2006/main" xmlns:r="http://schemas.openxmlformats.org/officeDocument/2006/relationships">
+  <p:cSld>
+    <p:spTree>
+      <p:nvGrpSpPr>
+        <p:cNvPr id="1" name=""/>
+        <p:cNvGrpSpPr/>
+        <p:nvPr/>
+      </p:nvGrpSpPr>
+      <p:grpSpPr>
+        <a:xfrm>
+          <a:off x="0" y="0"/>
+          <a:ext cx="0" cy="0"/>
+          <a:chOff x="0" y="0"/>
+          <a:chExt cx="0" cy="0"/>
+        </a:xfrm>
+      </p:grpSpPr>
+      <p:sp>
+        <p:nvSpPr>
+          <p:cNvPr id="2" name="Slide Image Placeholder 1"/>
+          <p:cNvSpPr>
+            <a:spLocks noGrp="1"/>
+          </p:cNvSpPr>
+          <p:nvPr>
+            <p:ph type="sldImg" idx="2"/>
+          </p:nvPr>
+        </p:nvSpPr>
+        <p:spPr/>
+      </p:sp>
+      <p:sp>
+        <p:nvSpPr>
+          <p:cNvPr id="3" name="Notes Placeholder 2"/>
+          <p:cNvSpPr>
+            <a:spLocks noGrp="1"/>
+          </p:cNvSpPr>
+          <p:nvPr>
+            <p:ph type="body" idx="3" sz="quarter"/>
+          </p:nvPr>
+        </p:nvSpPr>
+        <p:spPr/>
+        <p:txBody>
+          <a:bodyPr/>
+          <a:lstStyle/>
+          <a:p>
+            <a:r>
+              <a:t>Flask site. Animation: screenshots of board, seat map, refusal message. Live demo if network allows.</a:t>
+            </a:r>
+          </a:p>
+        </p:txBody>
+      </p:sp>
+      <p:sp>
+        <p:nvSpPr>
+          <p:cNvPr id="4" name="Slide Number Placeholder 3"/>
+          <p:cNvSpPr>
+            <a:spLocks noGrp="1"/>
+          </p:cNvSpPr>
+          <p:nvPr>
+            <p:ph type="sldNum" idx="5" sz="quarter"/>
+          </p:nvPr>
+        </p:nvSpPr>
+        <p:spPr/>
+      </p:sp>
+    </p:spTree>
+  </p:cSld>
+  <p:clrMapOvr>
+    <a:masterClrMapping/>
+  </p:clrMapOvr>
+</p:notes>
+</file>
+
+<file path=ppt/notesSlides/notesSlide11.xml><?xml version="1.0" encoding="utf-8"?>
+<p:notes xmlns:a="http://schemas.openxmlformats.org/drawingml/2006/main" xmlns:p="http://schemas.openxmlformats.org/presentationml/2006/main" xmlns:r="http://schemas.openxmlformats.org/officeDocument/2006/relationships">
+  <p:cSld>
+    <p:spTree>
+      <p:nvGrpSpPr>
+        <p:cNvPr id="1" name=""/>
+        <p:cNvGrpSpPr/>
+        <p:nvPr/>
+      </p:nvGrpSpPr>
+      <p:grpSpPr>
+        <a:xfrm>
+          <a:off x="0" y="0"/>
+          <a:ext cx="0" cy="0"/>
+          <a:chOff x="0" y="0"/>
+          <a:chExt cx="0" cy="0"/>
+        </a:xfrm>
+      </p:grpSpPr>
+      <p:sp>
+        <p:nvSpPr>
+          <p:cNvPr id="2" name="Slide Image Placeholder 1"/>
+          <p:cNvSpPr>
+            <a:spLocks noGrp="1"/>
+          </p:cNvSpPr>
+          <p:nvPr>
+            <p:ph type="sldImg" idx="2"/>
+          </p:nvPr>
+        </p:nvSpPr>
+        <p:spPr/>
+      </p:sp>
+      <p:sp>
+        <p:nvSpPr>
+          <p:cNvPr id="3" name="Notes Placeholder 2"/>
+          <p:cNvSpPr>
+            <a:spLocks noGrp="1"/>
+          </p:cNvSpPr>
+          <p:nvPr>
+            <p:ph type="body" idx="3" sz="quarter"/>
+          </p:nvPr>
+        </p:nvSpPr>
+        <p:spPr/>
+        <p:txBody>
+          <a:bodyPr/>
+          <a:lstStyle/>
+          <a:p>
+            <a:r>
+              <a:t>Result. Animation: checklist ticks. Close with the demo invitation.</a:t>
+            </a:r>
+          </a:p>
+        </p:txBody>
+      </p:sp>
+      <p:sp>
+        <p:nvSpPr>
+          <p:cNvPr id="4" name="Slide Number Placeholder 3"/>
+          <p:cNvSpPr>
+            <a:spLocks noGrp="1"/>
+          </p:cNvSpPr>
+          <p:nvPr>
+            <p:ph type="sldNum" idx="5" sz="quarter"/>
+          </p:nvPr>
+        </p:nvSpPr>
+        <p:spPr/>
+      </p:sp>
+    </p:spTree>
+  </p:cSld>
+  <p:clrMapOvr>
+    <a:masterClrMapping/>
+  </p:clrMapOvr>
+</p:notes>
+</file>
+
+<file path=ppt/notesSlides/notesSlide2.xml><?xml version="1.0" encoding="utf-8"?>
+<p:notes xmlns:a="http://schemas.openxmlformats.org/drawingml/2006/main" xmlns:p="http://schemas.openxmlformats.org/presentationml/2006/main" xmlns:r="http://schemas.openxmlformats.org/officeDocument/2006/relationships">
+  <p:cSld>
+    <p:spTree>
+      <p:nvGrpSpPr>
+        <p:cNvPr id="1" name=""/>
+        <p:cNvGrpSpPr/>
+        <p:nvPr/>
+      </p:nvGrpSpPr>
+      <p:grpSpPr>
+        <a:xfrm>
+          <a:off x="0" y="0"/>
+          <a:ext cx="0" cy="0"/>
+          <a:chOff x="0" y="0"/>
+          <a:chExt cx="0" cy="0"/>
+        </a:xfrm>
+      </p:grpSpPr>
+      <p:sp>
+        <p:nvSpPr>
+          <p:cNvPr id="2" name="Slide Image Placeholder 1"/>
+          <p:cNvSpPr>
+            <a:spLocks noGrp="1"/>
+          </p:cNvSpPr>
+          <p:nvPr>
+            <p:ph type="sldImg" idx="2"/>
+          </p:nvPr>
+        </p:nvSpPr>
+        <p:spPr/>
+      </p:sp>
+      <p:sp>
+        <p:nvSpPr>
+          <p:cNvPr id="3" name="Notes Placeholder 2"/>
+          <p:cNvSpPr>
+            <a:spLocks noGrp="1"/>
+          </p:cNvSpPr>
+          <p:nvPr>
+            <p:ph type="body" idx="3" sz="quarter"/>
+          </p:nvPr>
+        </p:nvSpPr>
+        <p:spPr/>
+        <p:txBody>
+          <a:bodyPr/>
+          <a:lstStyle/>
+          <a:p>
+            <a:r>
+              <a:t>Problem. Animation: each row wipes in with its mechanism. Stress: every failure maps to exactly one mechanism.</a:t>
+            </a:r>
+          </a:p>
+        </p:txBody>
+      </p:sp>
+      <p:sp>
+        <p:nvSpPr>
+          <p:cNvPr id="4" name="Slide Number Placeholder 3"/>
+          <p:cNvSpPr>
+            <a:spLocks noGrp="1"/>
+          </p:cNvSpPr>
+          <p:nvPr>
+            <p:ph type="sldNum" idx="5" sz="quarter"/>
+          </p:nvPr>
+        </p:nvSpPr>
+        <p:spPr/>
+      </p:sp>
+    </p:spTree>
+  </p:cSld>
+  <p:clrMapOvr>
+    <a:masterClrMapping/>
+  </p:clrMapOvr>
+</p:notes>
+</file>
+
+<file path=ppt/notesSlides/notesSlide3.xml><?xml version="1.0" encoding="utf-8"?>
+<p:notes xmlns:a="http://schemas.openxmlformats.org/drawingml/2006/main" xmlns:p="http://schemas.openxmlformats.org/presentationml/2006/main" xmlns:r="http://schemas.openxmlformats.org/officeDocument/2006/relationships">
+  <p:cSld>
+    <p:spTree>
+      <p:nvGrpSpPr>
+        <p:cNvPr id="1" name=""/>
+        <p:cNvGrpSpPr/>
+        <p:nvPr/>
+      </p:nvGrpSpPr>
+      <p:grpSpPr>
+        <a:xfrm>
+          <a:off x="0" y="0"/>
+          <a:ext cx="0" cy="0"/>
+          <a:chOff x="0" y="0"/>
+          <a:chExt cx="0" cy="0"/>
+        </a:xfrm>
+      </p:grpSpPr>
+      <p:sp>
+        <p:nvSpPr>
+          <p:cNvPr id="2" name="Slide Image Placeholder 1"/>
+          <p:cNvSpPr>
+            <a:spLocks noGrp="1"/>
+          </p:cNvSpPr>
+          <p:nvPr>
+            <p:ph type="sldImg" idx="2"/>
+          </p:nvPr>
+        </p:nvSpPr>
+        <p:spPr/>
+      </p:sp>
+      <p:sp>
+        <p:nvSpPr>
+          <p:cNvPr id="3" name="Notes Placeholder 2"/>
+          <p:cNvSpPr>
+            <a:spLocks noGrp="1"/>
+          </p:cNvSpPr>
+          <p:nvPr>
+            <p:ph type="body" idx="3" sz="quarter"/>
+          </p:nvPr>
+        </p:nvSpPr>
+        <p:spPr/>
+        <p:txBody>
+          <a:bodyPr/>
+          <a:lstStyle/>
+          <a:p>
+            <a:r>
+              <a:t>ER. Animation: entities fade in layer by layer (masters, operations, dependents). Point at the weak entity.</a:t>
+            </a:r>
+          </a:p>
+        </p:txBody>
+      </p:sp>
+      <p:sp>
+        <p:nvSpPr>
+          <p:cNvPr id="4" name="Slide Number Placeholder 3"/>
+          <p:cNvSpPr>
+            <a:spLocks noGrp="1"/>
+          </p:cNvSpPr>
+          <p:nvPr>
+            <p:ph type="sldNum" idx="5" sz="quarter"/>
+          </p:nvPr>
+        </p:nvSpPr>
+        <p:spPr/>
+      </p:sp>
+    </p:spTree>
+  </p:cSld>
+  <p:clrMapOvr>
+    <a:masterClrMapping/>
+  </p:clrMapOvr>
+</p:notes>
+</file>
+
+<file path=ppt/notesSlides/notesSlide4.xml><?xml version="1.0" encoding="utf-8"?>
+<p:notes xmlns:a="http://schemas.openxmlformats.org/drawingml/2006/main" xmlns:p="http://schemas.openxmlformats.org/presentationml/2006/main" xmlns:r="http://schemas.openxmlformats.org/officeDocument/2006/relationships">
+  <p:cSld>
+    <p:spTree>
+      <p:nvGrpSpPr>
+        <p:cNvPr id="1" name=""/>
+        <p:cNvGrpSpPr/>
+        <p:nvPr/>
+      </p:nvGrpSpPr>
+      <p:grpSpPr>
+        <a:xfrm>
+          <a:off x="0" y="0"/>
+          <a:ext cx="0" cy="0"/>
+          <a:chOff x="0" y="0"/>
+          <a:chExt cx="0" cy="0"/>
+        </a:xfrm>
+      </p:grpSpPr>
+      <p:sp>
+        <p:nvSpPr>
+          <p:cNvPr id="2" name="Slide Image Placeholder 1"/>
+          <p:cNvSpPr>
+            <a:spLocks noGrp="1"/>
+          </p:cNvSpPr>
+          <p:nvPr>
+            <p:ph type="sldImg" idx="2"/>
+          </p:nvPr>
+        </p:nvSpPr>
+        <p:spPr/>
+      </p:sp>
+      <p:sp>
+        <p:nvSpPr>
+          <p:cNvPr id="3" name="Notes Placeholder 2"/>
+          <p:cNvSpPr>
+            <a:spLocks noGrp="1"/>
+          </p:cNvSpPr>
+          <p:nvPr>
+            <p:ph type="body" idx="3" sz="quarter"/>
+          </p:nvPr>
+        </p:nvSpPr>
+        <p:spPr/>
+        <p:txBody>
+          <a:bodyPr/>
+          <a:lstStyle/>
+          <a:p>
+            <a:r>
+              <a:t>Schema table. Animation: rows appear one by one. Pause on the seat and gate UNIQUE rows.</a:t>
+            </a:r>
+          </a:p>
+        </p:txBody>
+      </p:sp>
+      <p:sp>
+        <p:nvSpPr>
+          <p:cNvPr id="4" name="Slide Number Placeholder 3"/>
+          <p:cNvSpPr>
+            <a:spLocks noGrp="1"/>
+          </p:cNvSpPr>
+          <p:nvPr>
+            <p:ph type="sldNum" idx="5" sz="quarter"/>
+          </p:nvPr>
+        </p:nvSpPr>
+        <p:spPr/>
+      </p:sp>
+    </p:spTree>
+  </p:cSld>
+  <p:clrMapOvr>
+    <a:masterClrMapping/>
+  </p:clrMapOvr>
+</p:notes>
+</file>
+
+<file path=ppt/notesSlides/notesSlide5.xml><?xml version="1.0" encoding="utf-8"?>
+<p:notes xmlns:a="http://schemas.openxmlformats.org/drawingml/2006/main" xmlns:p="http://schemas.openxmlformats.org/presentationml/2006/main" xmlns:r="http://schemas.openxmlformats.org/officeDocument/2006/relationships">
+  <p:cSld>
+    <p:spTree>
+      <p:nvGrpSpPr>
+        <p:cNvPr id="1" name=""/>
+        <p:cNvGrpSpPr/>
+        <p:nvPr/>
+      </p:nvGrpSpPr>
+      <p:grpSpPr>
+        <a:xfrm>
+          <a:off x="0" y="0"/>
+          <a:ext cx="0" cy="0"/>
+          <a:chOff x="0" y="0"/>
+          <a:chExt cx="0" cy="0"/>
+        </a:xfrm>
+      </p:grpSpPr>
+      <p:sp>
+        <p:nvSpPr>
+          <p:cNvPr id="2" name="Slide Image Placeholder 1"/>
+          <p:cNvSpPr>
+            <a:spLocks noGrp="1"/>
+          </p:cNvSpPr>
+          <p:nvPr>
+            <p:ph type="sldImg" idx="2"/>
+          </p:nvPr>
+        </p:nvSpPr>
+        <p:spPr/>
+      </p:sp>
+      <p:sp>
+        <p:nvSpPr>
+          <p:cNvPr id="3" name="Notes Placeholder 2"/>
+          <p:cNvSpPr>
+            <a:spLocks noGrp="1"/>
+          </p:cNvSpPr>
+          <p:nvPr>
+            <p:ph type="body" idx="3" sz="quarter"/>
+          </p:nvPr>
+        </p:nvSpPr>
+        <p:spPr/>
+        <p:txBody>
+          <a:bodyPr/>
+          <a:lstStyle/>
+          <a:p>
+            <a:r>
+              <a:t>Scale. Animation: count-up effect on 336 / 34k if available. Key line: scale is a knob, not a rewrite.</a:t>
+            </a:r>
+          </a:p>
+        </p:txBody>
+      </p:sp>
+      <p:sp>
+        <p:nvSpPr>
+          <p:cNvPr id="4" name="Slide Number Placeholder 3"/>
+          <p:cNvSpPr>
+            <a:spLocks noGrp="1"/>
+          </p:cNvSpPr>
+          <p:nvPr>
+            <p:ph type="sldNum" idx="5" sz="quarter"/>
+          </p:nvPr>
+        </p:nvSpPr>
+        <p:spPr/>
+      </p:sp>
+    </p:spTree>
+  </p:cSld>
+  <p:clrMapOvr>
+    <a:masterClrMapping/>
+  </p:clrMapOvr>
+</p:notes>
+</file>
+
+<file path=ppt/notesSlides/notesSlide6.xml><?xml version="1.0" encoding="utf-8"?>
+<p:notes xmlns:a="http://schemas.openxmlformats.org/drawingml/2006/main" xmlns:p="http://schemas.openxmlformats.org/presentationml/2006/main" xmlns:r="http://schemas.openxmlformats.org/officeDocument/2006/relationships">
+  <p:cSld>
+    <p:spTree>
+      <p:nvGrpSpPr>
+        <p:cNvPr id="1" name=""/>
+        <p:cNvGrpSpPr/>
+        <p:nvPr/>
+      </p:nvGrpSpPr>
+      <p:grpSpPr>
+        <a:xfrm>
+          <a:off x="0" y="0"/>
+          <a:ext cx="0" cy="0"/>
+          <a:chOff x="0" y="0"/>
+          <a:chExt cx="0" cy="0"/>
+        </a:xfrm>
+      </p:grpSpPr>
+      <p:sp>
+        <p:nvSpPr>
+          <p:cNvPr id="2" name="Slide Image Placeholder 1"/>
+          <p:cNvSpPr>
+            <a:spLocks noGrp="1"/>
+          </p:cNvSpPr>
+          <p:nvPr>
+            <p:ph type="sldImg" idx="2"/>
+          </p:nvPr>
+        </p:nvSpPr>
+        <p:spPr/>
+      </p:sp>
+      <p:sp>
+        <p:nvSpPr>
+          <p:cNvPr id="3" name="Notes Placeholder 2"/>
+          <p:cNvSpPr>
+            <a:spLocks noGrp="1"/>
+          </p:cNvSpPr>
+          <p:nvPr>
+            <p:ph type="body" idx="3" sz="quarter"/>
+          </p:nvPr>
+        </p:nvSpPr>
+        <p:spPr/>
+        <p:txBody>
+          <a:bodyPr/>
+          <a:lstStyle/>
+          <a:p>
+            <a:r>
+              <a:t>Advanced SQL. Animation: each bullet with its code snippet. Demo the trigger refusal live if possible.</a:t>
+            </a:r>
+          </a:p>
+        </p:txBody>
+      </p:sp>
+      <p:sp>
+        <p:nvSpPr>
+          <p:cNvPr id="4" name="Slide Number Placeholder 3"/>
+          <p:cNvSpPr>
+            <a:spLocks noGrp="1"/>
+          </p:cNvSpPr>
+          <p:nvPr>
+            <p:ph type="sldNum" idx="5" sz="quarter"/>
+          </p:nvPr>
+        </p:nvSpPr>
+        <p:spPr/>
+      </p:sp>
+    </p:spTree>
+  </p:cSld>
+  <p:clrMapOvr>
+    <a:masterClrMapping/>
+  </p:clrMapOvr>
+</p:notes>
+</file>
+
+<file path=ppt/notesSlides/notesSlide7.xml><?xml version="1.0" encoding="utf-8"?>
+<p:notes xmlns:a="http://schemas.openxmlformats.org/drawingml/2006/main" xmlns:p="http://schemas.openxmlformats.org/presentationml/2006/main" xmlns:r="http://schemas.openxmlformats.org/officeDocument/2006/relationships">
+  <p:cSld>
+    <p:spTree>
+      <p:nvGrpSpPr>
+        <p:cNvPr id="1" name=""/>
+        <p:cNvGrpSpPr/>
+        <p:nvPr/>
+      </p:nvGrpSpPr>
+      <p:grpSpPr>
+        <a:xfrm>
+          <a:off x="0" y="0"/>
+          <a:ext cx="0" cy="0"/>
+          <a:chOff x="0" y="0"/>
+          <a:chExt cx="0" cy="0"/>
+        </a:xfrm>
+      </p:grpSpPr>
+      <p:sp>
+        <p:nvSpPr>
+          <p:cNvPr id="2" name="Slide Image Placeholder 1"/>
+          <p:cNvSpPr>
+            <a:spLocks noGrp="1"/>
+          </p:cNvSpPr>
+          <p:nvPr>
+            <p:ph type="sldImg" idx="2"/>
+          </p:nvPr>
+        </p:nvSpPr>
+        <p:spPr/>
+      </p:sp>
+      <p:sp>
+        <p:nvSpPr>
+          <p:cNvPr id="3" name="Notes Placeholder 2"/>
+          <p:cNvSpPr>
+            <a:spLocks noGrp="1"/>
+          </p:cNvSpPr>
+          <p:nvPr>
+            <p:ph type="body" idx="3" sz="quarter"/>
+          </p:nvPr>
+        </p:nvSpPr>
+        <p:spPr/>
+        <p:txBody>
+          <a:bodyPr/>
+          <a:lstStyle/>
+          <a:p>
+            <a:r>
+              <a:t>Transactions. Animation: Demo B rollback as a two-step reveal. The seat stays free.</a:t>
+            </a:r>
+          </a:p>
+        </p:txBody>
+      </p:sp>
+      <p:sp>
+        <p:nvSpPr>
+          <p:cNvPr id="4" name="Slide Number Placeholder 3"/>
+          <p:cNvSpPr>
+            <a:spLocks noGrp="1"/>
+          </p:cNvSpPr>
+          <p:nvPr>
+            <p:ph type="sldNum" idx="5" sz="quarter"/>
+          </p:nvPr>
+        </p:nvSpPr>
+        <p:spPr/>
+      </p:sp>
+    </p:spTree>
+  </p:cSld>
+  <p:clrMapOvr>
+    <a:masterClrMapping/>
+  </p:clrMapOvr>
+</p:notes>
+</file>
+
+<file path=ppt/notesSlides/notesSlide8.xml><?xml version="1.0" encoding="utf-8"?>
+<p:notes xmlns:a="http://schemas.openxmlformats.org/drawingml/2006/main" xmlns:p="http://schemas.openxmlformats.org/presentationml/2006/main" xmlns:r="http://schemas.openxmlformats.org/officeDocument/2006/relationships">
+  <p:cSld>
+    <p:spTree>
+      <p:nvGrpSpPr>
+        <p:cNvPr id="1" name=""/>
+        <p:cNvGrpSpPr/>
+        <p:nvPr/>
+      </p:nvGrpSpPr>
+      <p:grpSpPr>
+        <a:xfrm>
+          <a:off x="0" y="0"/>
+          <a:ext cx="0" cy="0"/>
+          <a:chOff x="0" y="0"/>
+          <a:chExt cx="0" cy="0"/>
+        </a:xfrm>
+      </p:grpSpPr>
+      <p:sp>
+        <p:nvSpPr>
+          <p:cNvPr id="2" name="Slide Image Placeholder 1"/>
+          <p:cNvSpPr>
+            <a:spLocks noGrp="1"/>
+          </p:cNvSpPr>
+          <p:nvPr>
+            <p:ph type="sldImg" idx="2"/>
+          </p:nvPr>
+        </p:nvSpPr>
+        <p:spPr/>
+      </p:sp>
+      <p:sp>
+        <p:nvSpPr>
+          <p:cNvPr id="3" name="Notes Placeholder 2"/>
+          <p:cNvSpPr>
+            <a:spLocks noGrp="1"/>
+          </p:cNvSpPr>
+          <p:nvPr>
+            <p:ph type="body" idx="3" sz="quarter"/>
+          </p:nvPr>
+        </p:nvSpPr>
+        <p:spPr/>
+        <p:txBody>
+          <a:bodyPr/>
+          <a:lstStyle/>
+          <a:p>
+            <a:r>
+              <a:t>Indexing. Animation: before/after EXPLAIN bars. Say the FK line out loud: no cargo cult.</a:t>
+            </a:r>
+          </a:p>
+        </p:txBody>
+      </p:sp>
+      <p:sp>
+        <p:nvSpPr>
+          <p:cNvPr id="4" name="Slide Number Placeholder 3"/>
+          <p:cNvSpPr>
+            <a:spLocks noGrp="1"/>
+          </p:cNvSpPr>
+          <p:nvPr>
+            <p:ph type="sldNum" idx="5" sz="quarter"/>
+          </p:nvPr>
+        </p:nvSpPr>
+        <p:spPr/>
+      </p:sp>
+    </p:spTree>
+  </p:cSld>
+  <p:clrMapOvr>
+    <a:masterClrMapping/>
+  </p:clrMapOvr>
+</p:notes>
+</file>
+
+<file path=ppt/notesSlides/notesSlide9.xml><?xml version="1.0" encoding="utf-8"?>
+<p:notes xmlns:a="http://schemas.openxmlformats.org/drawingml/2006/main" xmlns:p="http://schemas.openxmlformats.org/presentationml/2006/main" xmlns:r="http://schemas.openxmlformats.org/officeDocument/2006/relationships">
+  <p:cSld>
+    <p:spTree>
+      <p:nvGrpSpPr>
+        <p:cNvPr id="1" name=""/>
+        <p:cNvGrpSpPr/>
+        <p:nvPr/>
+      </p:nvGrpSpPr>
+      <p:grpSpPr>
+        <a:xfrm>
+          <a:off x="0" y="0"/>
+          <a:ext cx="0" cy="0"/>
+          <a:chOff x="0" y="0"/>
+          <a:chExt cx="0" cy="0"/>
+        </a:xfrm>
+      </p:grpSpPr>
+      <p:sp>
+        <p:nvSpPr>
+          <p:cNvPr id="2" name="Slide Image Placeholder 1"/>
+          <p:cNvSpPr>
+            <a:spLocks noGrp="1"/>
+          </p:cNvSpPr>
+          <p:nvPr>
+            <p:ph type="sldImg" idx="2"/>
+          </p:nvPr>
+        </p:nvSpPr>
+        <p:spPr/>
+      </p:sp>
+      <p:sp>
+        <p:nvSpPr>
+          <p:cNvPr id="3" name="Notes Placeholder 2"/>
+          <p:cNvSpPr>
+            <a:spLocks noGrp="1"/>
+          </p:cNvSpPr>
+          <p:nvPr>
+            <p:ph type="body" idx="3" sz="quarter"/>
+          </p:nvPr>
+        </p:nvSpPr>
+        <p:spPr/>
+        <p:txBody>
+          <a:bodyPr/>
+          <a:lstStyle/>
+          <a:p>
+            <a:r>
+              <a:t>Access + testing. Animation: grant table, then the denied INSERT. 30 checks, all expected-first.</a:t>
+            </a:r>
+          </a:p>
+        </p:txBody>
+      </p:sp>
+      <p:sp>
+        <p:nvSpPr>
+          <p:cNvPr id="4" name="Slide Number Placeholder 3"/>
+          <p:cNvSpPr>
+            <a:spLocks noGrp="1"/>
+          </p:cNvSpPr>
+          <p:nvPr>
+            <p:ph type="sldNum" idx="5" sz="quarter"/>
+          </p:nvPr>
+        </p:nvSpPr>
+        <p:spPr/>
+      </p:sp>
+    </p:spTree>
+  </p:cSld>
+  <p:clrMapOvr>
+    <a:masterClrMapping/>
+  </p:clrMapOvr>
+</p:notes>
 </file>
 
 <file path=ppt/slideLayouts/slideLayout1.xml><?xml version="1.0" encoding="utf-8"?>
@@ -3204,7 +4324,7 @@
                   <a:srgbClr val="CFE3F7"/>
                 </a:solidFill>
               </a:rPr>
-              <a:t>Multi-airport database · 16 tables · 140 departures · ~14,000 bookings</a:t>
+              <a:t>Multi-airport database · 16 tables · 336 departures · ~34,000 bookings</a:t>
             </a:r>
           </a:p>
           <a:p>
@@ -6562,4 +7682,324 @@
   </a:objectDefaults>
   <a:extraClrSchemeLst/>
 </a:theme>
+</file>
+
+<file path=ppt/theme/theme2.xml><?xml version="1.0" encoding="utf-8"?>
+<a:theme xmlns:a="http://schemas.openxmlformats.org/drawingml/2006/main" name="Office Theme">
+  <a:themeElements>
+    <a:clrScheme name="Office">
+      <a:dk1>
+        <a:sysClr val="windowText" lastClr="000000"/>
+      </a:dk1>
+      <a:lt1>
+        <a:sysClr val="window" lastClr="FFFFFF"/>
+      </a:lt1>
+      <a:dk2>
+        <a:srgbClr val="1F497D"/>
+      </a:dk2>
+      <a:lt2>
+        <a:srgbClr val="EEECE1"/>
+      </a:lt2>
+      <a:accent1>
+        <a:srgbClr val="4F81BD"/>
+      </a:accent1>
+      <a:accent2>
+        <a:srgbClr val="C0504D"/>
+      </a:accent2>
+      <a:accent3>
+        <a:srgbClr val="9BBB59"/>
+      </a:accent3>
+      <a:accent4>
+        <a:srgbClr val="8064A2"/>
+      </a:accent4>
+      <a:accent5>
+        <a:srgbClr val="4BACC6"/>
+      </a:accent5>
+      <a:accent6>
+        <a:srgbClr val="F79646"/>
+      </a:accent6>
+      <a:hlink>
+        <a:srgbClr val="0000FF"/>
+      </a:hlink>
+      <a:folHlink>
+        <a:srgbClr val="800080"/>
+      </a:folHlink>
+    </a:clrScheme>
+    <a:fontScheme name="Office">
+      <a:majorFont>
+        <a:latin typeface="Calibri"/>
+        <a:ea typeface=""/>
+        <a:cs typeface=""/>
+        <a:font script="Jpan" typeface="ＭＳ Ｐゴシック"/>
+        <a:font script="Hang" typeface="맑은 고딕"/>
+        <a:font script="Hans" typeface="宋体"/>
+        <a:font script="Hant" typeface="新細明體"/>
+        <a:font script="Arab" typeface="Times New Roman"/>
+        <a:font script="Hebr" typeface="Times New Roman"/>
+        <a:font script="Thai" typeface="Angsana New"/>
+        <a:font script="Ethi" typeface="Nyala"/>
+        <a:font script="Beng" typeface="Vrinda"/>
+        <a:font script="Gujr" typeface="Shruti"/>
+        <a:font script="Khmr" typeface="MoolBoran"/>
+        <a:font script="Knda" typeface="Tunga"/>
+        <a:font script="Guru" typeface="Raavi"/>
+        <a:font script="Cans" typeface="Euphemia"/>
+        <a:font script="Cher" typeface="Plantagenet Cherokee"/>
+        <a:font script="Yiii" typeface="Microsoft Yi Baiti"/>
+        <a:font script="Tibt" typeface="Microsoft Himalaya"/>
+        <a:font script="Thaa" typeface="MV Boli"/>
+        <a:font script="Deva" typeface="Mangal"/>
+        <a:font script="Telu" typeface="Gautami"/>
+        <a:font script="Taml" typeface="Latha"/>
+        <a:font script="Syrc" typeface="Estrangelo Edessa"/>
+        <a:font script="Orya" typeface="Kalinga"/>
+        <a:font script="Mlym" typeface="Kartika"/>
+        <a:font script="Laoo" typeface="DokChampa"/>
+        <a:font script="Sinh" typeface="Iskoola Pota"/>
+        <a:font script="Mong" typeface="Mongolian Baiti"/>
+        <a:font script="Viet" typeface="Times New Roman"/>
+        <a:font script="Uigh" typeface="Microsoft Uighur"/>
+        <a:font script="Geor" typeface="Sylfaen"/>
+      </a:majorFont>
+      <a:minorFont>
+        <a:latin typeface="Calibri"/>
+        <a:ea typeface=""/>
+        <a:cs typeface=""/>
+        <a:font script="Jpan" typeface="ＭＳ Ｐゴシック"/>
+        <a:font script="Hang" typeface="맑은 고딕"/>
+        <a:font script="Hans" typeface="宋体"/>
+        <a:font script="Hant" typeface="新細明體"/>
+        <a:font script="Arab" typeface="Arial"/>
+        <a:font script="Hebr" typeface="Arial"/>
+        <a:font script="Thai" typeface="Cordia New"/>
+        <a:font script="Ethi" typeface="Nyala"/>
+        <a:font script="Beng" typeface="Vrinda"/>
+        <a:font script="Gujr" typeface="Shruti"/>
+        <a:font script="Khmr" typeface="DaunPenh"/>
+        <a:font script="Knda" typeface="Tunga"/>
+        <a:font script="Guru" typeface="Raavi"/>
+        <a:font script="Cans" typeface="Euphemia"/>
+        <a:font script="Cher" typeface="Plantagenet Cherokee"/>
+        <a:font script="Yiii" typeface="Microsoft Yi Baiti"/>
+        <a:font script="Tibt" typeface="Microsoft Himalaya"/>
+        <a:font script="Thaa" typeface="MV Boli"/>
+        <a:font script="Deva" typeface="Mangal"/>
+        <a:font script="Telu" typeface="Gautami"/>
+        <a:font script="Taml" typeface="Latha"/>
+        <a:font script="Syrc" typeface="Estrangelo Edessa"/>
+        <a:font script="Orya" typeface="Kalinga"/>
+        <a:font script="Mlym" typeface="Kartika"/>
+        <a:font script="Laoo" typeface="DokChampa"/>
+        <a:font script="Sinh" typeface="Iskoola Pota"/>
+        <a:font script="Mong" typeface="Mongolian Baiti"/>
+        <a:font script="Viet" typeface="Arial"/>
+        <a:font script="Uigh" typeface="Microsoft Uighur"/>
+        <a:font script="Geor" typeface="Sylfaen"/>
+      </a:minorFont>
+    </a:fontScheme>
+    <a:fmtScheme name="Office">
+      <a:fillStyleLst>
+        <a:solidFill>
+          <a:schemeClr val="phClr"/>
+        </a:solidFill>
+        <a:gradFill rotWithShape="1">
+          <a:gsLst>
+            <a:gs pos="0">
+              <a:schemeClr val="phClr">
+                <a:tint val="50000"/>
+                <a:satMod val="300000"/>
+              </a:schemeClr>
+            </a:gs>
+            <a:gs pos="35000">
+              <a:schemeClr val="phClr">
+                <a:tint val="37000"/>
+                <a:satMod val="300000"/>
+              </a:schemeClr>
+            </a:gs>
+            <a:gs pos="100000">
+              <a:schemeClr val="phClr">
+                <a:tint val="15000"/>
+                <a:satMod val="350000"/>
+              </a:schemeClr>
+            </a:gs>
+          </a:gsLst>
+          <a:lin ang="16200000" scaled="1"/>
+        </a:gradFill>
+        <a:gradFill rotWithShape="1">
+          <a:gsLst>
+            <a:gs pos="0">
+              <a:schemeClr val="phClr">
+                <a:tint val="100000"/>
+                <a:shade val="100000"/>
+                <a:satMod val="130000"/>
+              </a:schemeClr>
+            </a:gs>
+            <a:gs pos="100000">
+              <a:schemeClr val="phClr">
+                <a:tint val="50000"/>
+                <a:shade val="100000"/>
+                <a:satMod val="350000"/>
+              </a:schemeClr>
+            </a:gs>
+          </a:gsLst>
+          <a:lin ang="16200000" scaled="0"/>
+        </a:gradFill>
+      </a:fillStyleLst>
+      <a:lnStyleLst>
+        <a:ln w="9525" cap="flat" cmpd="sng" algn="ctr">
+          <a:solidFill>
+            <a:schemeClr val="phClr">
+              <a:shade val="95000"/>
+              <a:satMod val="105000"/>
+            </a:schemeClr>
+          </a:solidFill>
+          <a:prstDash val="solid"/>
+        </a:ln>
+        <a:ln w="25400" cap="flat" cmpd="sng" algn="ctr">
+          <a:solidFill>
+            <a:schemeClr val="phClr"/>
+          </a:solidFill>
+          <a:prstDash val="solid"/>
+        </a:ln>
+        <a:ln w="38100" cap="flat" cmpd="sng" algn="ctr">
+          <a:solidFill>
+            <a:schemeClr val="phClr"/>
+          </a:solidFill>
+          <a:prstDash val="solid"/>
+        </a:ln>
+      </a:lnStyleLst>
+      <a:effectStyleLst>
+        <a:effectStyle>
+          <a:effectLst>
+            <a:outerShdw blurRad="40000" dist="20000" dir="5400000" rotWithShape="0">
+              <a:srgbClr val="000000">
+                <a:alpha val="38000"/>
+              </a:srgbClr>
+            </a:outerShdw>
+          </a:effectLst>
+        </a:effectStyle>
+        <a:effectStyle>
+          <a:effectLst>
+            <a:outerShdw blurRad="40000" dist="23000" dir="5400000" rotWithShape="0">
+              <a:srgbClr val="000000">
+                <a:alpha val="35000"/>
+              </a:srgbClr>
+            </a:outerShdw>
+          </a:effectLst>
+        </a:effectStyle>
+        <a:effectStyle>
+          <a:effectLst>
+            <a:outerShdw blurRad="40000" dist="23000" dir="5400000" rotWithShape="0">
+              <a:srgbClr val="000000">
+                <a:alpha val="35000"/>
+              </a:srgbClr>
+            </a:outerShdw>
+          </a:effectLst>
+          <a:scene3d>
+            <a:camera prst="orthographicFront">
+              <a:rot lat="0" lon="0" rev="0"/>
+            </a:camera>
+            <a:lightRig rig="threePt" dir="t">
+              <a:rot lat="0" lon="0" rev="1200000"/>
+            </a:lightRig>
+          </a:scene3d>
+          <a:sp3d>
+            <a:bevelT w="63500" h="25400"/>
+          </a:sp3d>
+        </a:effectStyle>
+      </a:effectStyleLst>
+      <a:bgFillStyleLst>
+        <a:solidFill>
+          <a:schemeClr val="phClr"/>
+        </a:solidFill>
+        <a:gradFill rotWithShape="1">
+          <a:gsLst>
+            <a:gs pos="0">
+              <a:schemeClr val="phClr">
+                <a:tint val="40000"/>
+                <a:satMod val="350000"/>
+              </a:schemeClr>
+            </a:gs>
+            <a:gs pos="40000">
+              <a:schemeClr val="phClr">
+                <a:tint val="45000"/>
+                <a:shade val="99000"/>
+                <a:satMod val="350000"/>
+              </a:schemeClr>
+            </a:gs>
+            <a:gs pos="100000">
+              <a:schemeClr val="phClr">
+                <a:shade val="20000"/>
+                <a:satMod val="255000"/>
+              </a:schemeClr>
+            </a:gs>
+          </a:gsLst>
+          <a:path path="circle">
+            <a:fillToRect l="50000" t="-80000" r="50000" b="180000"/>
+          </a:path>
+        </a:gradFill>
+        <a:gradFill rotWithShape="1">
+          <a:gsLst>
+            <a:gs pos="0">
+              <a:schemeClr val="phClr">
+                <a:tint val="80000"/>
+                <a:satMod val="300000"/>
+              </a:schemeClr>
+            </a:gs>
+            <a:gs pos="100000">
+              <a:schemeClr val="phClr">
+                <a:shade val="30000"/>
+                <a:satMod val="200000"/>
+              </a:schemeClr>
+            </a:gs>
+          </a:gsLst>
+          <a:path path="circle">
+            <a:fillToRect l="50000" t="50000" r="50000" b="50000"/>
+          </a:path>
+        </a:gradFill>
+      </a:bgFillStyleLst>
+    </a:fmtScheme>
+  </a:themeElements>
+  <a:objectDefaults>
+    <a:spDef>
+      <a:spPr/>
+      <a:bodyPr/>
+      <a:lstStyle/>
+      <a:style>
+        <a:lnRef idx="1">
+          <a:schemeClr val="accent1"/>
+        </a:lnRef>
+        <a:fillRef idx="3">
+          <a:schemeClr val="accent1"/>
+        </a:fillRef>
+        <a:effectRef idx="2">
+          <a:schemeClr val="accent1"/>
+        </a:effectRef>
+        <a:fontRef idx="minor">
+          <a:schemeClr val="lt1"/>
+        </a:fontRef>
+      </a:style>
+    </a:spDef>
+    <a:lnDef>
+      <a:spPr/>
+      <a:bodyPr/>
+      <a:lstStyle/>
+      <a:style>
+        <a:lnRef idx="2">
+          <a:schemeClr val="accent1"/>
+        </a:lnRef>
+        <a:fillRef idx="0">
+          <a:schemeClr val="accent1"/>
+        </a:fillRef>
+        <a:effectRef idx="1">
+          <a:schemeClr val="accent1"/>
+        </a:effectRef>
+        <a:fontRef idx="minor">
+          <a:schemeClr val="tx1"/>
+        </a:fontRef>
+      </a:style>
+    </a:lnDef>
+  </a:objectDefaults>
+  <a:extraClrSchemeLst/>
+</a:theme>
 </file>
</xml_diff>

<commit_message>
Latest build: flow-layout Chen ER, SkyRoute submission title, Flask seat/XSS/edit/test fixes - 28 checks green
</commit_message>
<xml_diff>
--- a/dbms/docs/SkyRoute_Slides.pptx
+++ b/dbms/docs/SkyRoute_Slides.pptx
@@ -582,7 +582,7 @@
           <a:lstStyle/>
           <a:p>
             <a:r>
-              <a:t>Flask site. Animation: screenshots of board, seat map, refusal message. Live demo if network allows.</a:t>
+              <a:t>Flask site. Animation: login gate, manifest table reveal. Live demo: traveler books, staff checks in from the manifest.</a:t>
             </a:r>
           </a:p>
         </p:txBody>
@@ -4309,7 +4309,7 @@
                   <a:srgbClr val="FFFFFF"/>
                 </a:solidFill>
               </a:rPr>
-              <a:t>Airline Ticket &amp; Baggage System</a:t>
+              <a:t>Airline Booking, Baggage &amp; Staff Operations</a:t>
             </a:r>
           </a:p>
           <a:p>
@@ -4339,7 +4339,7 @@
                   <a:srgbClr val="CFE3F7"/>
                 </a:solidFill>
               </a:rPr>
-              <a:t>Views · trigger · procedure · transactions · indexes · Flask booking site</a:t>
+              <a:t>Views · trigger · procedure · transactions · indexes · Flask staff portal</a:t>
             </a:r>
           </a:p>
         </p:txBody>
@@ -4466,7 +4466,7 @@
                   <a:srgbClr val="FFFFFF"/>
                 </a:solidFill>
               </a:rPr>
-              <a:t>Flask booking site: the database, clickable</a:t>
+              <a:t>Flask site: staff portal + traveler login</a:t>
             </a:r>
           </a:p>
         </p:txBody>
@@ -4537,7 +4537,7 @@
                   <a:srgbClr val="0F2540"/>
                 </a:solidFill>
               </a:rPr>
-              <a:t>▸ 3 steps  </a:t>
+              <a:t>▸ Airplane Management System  </a:t>
             </a:r>
             <a:r>
               <a:rPr sz="1900">
@@ -4545,7 +4545,7 @@
                   <a:srgbClr val="222222"/>
                 </a:solidFill>
               </a:rPr>
-              <a:t>Search → seat map → My bookings (http://127.0.0.1:5000).</a:t>
+              <a:t>staff portal (PIN) + traveler login (ID), http://127.0.0.1:5000.</a:t>
             </a:r>
           </a:p>
           <a:p>
@@ -4560,7 +4560,7 @@
                   <a:srgbClr val="0F2540"/>
                 </a:solidFill>
               </a:rPr>
-              <a:t>▸ Seat map  </a:t>
+              <a:t>▸ Manifest  </a:t>
             </a:r>
             <a:r>
               <a:rPr sz="1900">
@@ -4568,7 +4568,7 @@
                   <a:srgbClr val="222222"/>
                 </a:solidFill>
               </a:rPr>
-              <a:t>grey seats are the UNIQUE key made visible.</a:t>
+              <a:t>pick any departure: every passenger, seat, bag, payment.</a:t>
             </a:r>
           </a:p>
           <a:p>
@@ -4583,7 +4583,7 @@
                   <a:srgbClr val="0F2540"/>
                 </a:solidFill>
               </a:rPr>
-              <a:t>▸ CRUD + fee  </a:t>
+              <a:t>▸ Privacy  </a:t>
             </a:r>
             <a:r>
               <a:rPr sz="1900">
@@ -4591,7 +4591,7 @@
                   <a:srgbClr val="222222"/>
                 </a:solidFill>
               </a:rPr>
-              <a:t>edit · cancel · delete · 25 kg bag = Rs 2,500 fee.</a:t>
+              <a:t>travelers see only their own bookings; staff sees all.</a:t>
             </a:r>
           </a:p>
           <a:p>
@@ -4606,7 +4606,7 @@
                   <a:srgbClr val="0F2540"/>
                 </a:solidFill>
               </a:rPr>
-              <a:t>▸ 24 tests  </a:t>
+              <a:t>▸ 28 tests  </a:t>
             </a:r>
             <a:r>
               <a:rPr sz="1900">
@@ -4843,7 +4843,7 @@
                   <a:srgbClr val="222222"/>
                 </a:solidFill>
               </a:rPr>
-              <a:t>~14k bookings answered in single queries.</a:t>
+              <a:t>~34k bookings answered in single queries.</a:t>
             </a:r>
           </a:p>
           <a:p>
@@ -4866,7 +4866,7 @@
                   <a:srgbClr val="222222"/>
                 </a:solidFill>
               </a:rPr>
-              <a:t>live demo: board → book 12A → re-book 12A (refused) → fee receipt.</a:t>
+              <a:t>live demo: login → book → re-book (refused) → manifest.</a:t>
             </a:r>
           </a:p>
         </p:txBody>
@@ -5439,7 +5439,7 @@
                   <a:srgbClr val="222222"/>
                 </a:solidFill>
               </a:rPr>
-              <a:t>Employee supertype + Pilot / Crew / Ground subtypes.</a:t>
+              <a:t>Employees + three role tables, 1-1 on the shared key.</a:t>
             </a:r>
           </a:p>
         </p:txBody>
@@ -6274,7 +6274,7 @@
                   <a:srgbClr val="222222"/>
                 </a:solidFill>
               </a:rPr>
-              <a:t>deterministic (seed 42): 14 days, 35–80% load factors.</a:t>
+              <a:t>deterministic (seed 42): 21 days, 35–80% load factors.</a:t>
             </a:r>
           </a:p>
           <a:p>

</xml_diff>